<commit_message>
docs: add VM guest software-render architecture with SwiftShader
Autonomously-by: Cursor-Grok:4.6

Co-authored-by: fangyushanghai <fangyushanghai@gmail.com>
</commit_message>
<xml_diff>
--- a/docs/assets/android-graphics-stack-wireframe.pptx
+++ b/docs/assets/android-graphics-stack-wireframe.pptx
@@ -9,6 +9,7 @@
     <p:sldId id="257" r:id="rId8"/>
     <p:sldId id="258" r:id="rId9"/>
     <p:sldId id="259" r:id="rId10"/>
+    <p:sldId id="260" r:id="rId11"/>
   </p:sldIdLst>
   <p:sldSz cx="14630400" cy="8229600" type="screen4x3"/>
   <p:notesSz cx="6858000" cy="9144000"/>
@@ -4141,8 +4142,8 @@
         </p:nvSpPr>
         <p:spPr>
           <a:xfrm>
-            <a:off x="3246120" y="3520440"/>
-            <a:ext cx="1965960" cy="566928"/>
+            <a:off x="3246120" y="3401568"/>
+            <a:ext cx="1965960" cy="457200"/>
           </a:xfrm>
           <a:prstGeom prst="roundRect">
             <a:avLst>
@@ -4178,7 +4179,7 @@
           <a:p>
             <a:pPr algn="ctr"/>
             <a:r>
-              <a:rPr sz="1300" b="1">
+              <a:rPr sz="1200" b="1">
                 <a:solidFill>
                   <a:srgbClr val="222222"/>
                 </a:solidFill>
@@ -5337,7 +5338,7 @@
         <p:spPr>
           <a:xfrm>
             <a:off x="3223260" y="2770632"/>
-            <a:ext cx="1005840" cy="749808"/>
+            <a:ext cx="1005840" cy="630936"/>
           </a:xfrm>
           <a:prstGeom prst="line">
             <a:avLst/>
@@ -5373,7 +5374,7 @@
         <p:spPr>
           <a:xfrm flipH="1">
             <a:off x="4549140" y="2770632"/>
-            <a:ext cx="45720" cy="749808"/>
+            <a:ext cx="45720" cy="630936"/>
           </a:xfrm>
           <a:prstGeom prst="line">
             <a:avLst/>
@@ -5481,7 +5482,7 @@
         <p:spPr>
           <a:xfrm>
             <a:off x="5920740" y="2770632"/>
-            <a:ext cx="0" cy="1033272"/>
+            <a:ext cx="0" cy="859536"/>
           </a:xfrm>
           <a:prstGeom prst="line">
             <a:avLst/>
@@ -5515,7 +5516,7 @@
         </p:nvCxnSpPr>
         <p:spPr>
           <a:xfrm flipH="1">
-            <a:off x="5463540" y="3803904"/>
+            <a:off x="5463540" y="3630168"/>
             <a:ext cx="457200" cy="0"/>
           </a:xfrm>
           <a:prstGeom prst="line">
@@ -5550,8 +5551,8 @@
         </p:nvCxnSpPr>
         <p:spPr>
           <a:xfrm>
-            <a:off x="5463540" y="3803904"/>
-            <a:ext cx="0" cy="2185416"/>
+            <a:off x="5463540" y="3630168"/>
+            <a:ext cx="0" cy="2359152"/>
           </a:xfrm>
           <a:prstGeom prst="line">
             <a:avLst/>
@@ -5586,8 +5587,8 @@
         </p:nvCxnSpPr>
         <p:spPr>
           <a:xfrm>
-            <a:off x="4229100" y="4087368"/>
-            <a:ext cx="1234440" cy="1901952"/>
+            <a:off x="4229100" y="3858768"/>
+            <a:ext cx="1234440" cy="2130552"/>
           </a:xfrm>
           <a:prstGeom prst="line">
             <a:avLst/>
@@ -5910,7 +5911,7 @@
         </p:nvCxnSpPr>
         <p:spPr>
           <a:xfrm>
-            <a:off x="5212079" y="3803904"/>
+            <a:off x="5212079" y="3630168"/>
             <a:ext cx="1691641" cy="0"/>
           </a:xfrm>
           <a:prstGeom prst="line">
@@ -5946,8 +5947,8 @@
         </p:nvSpPr>
         <p:spPr>
           <a:xfrm>
-            <a:off x="5257799" y="3264408"/>
-            <a:ext cx="1005840" cy="237744"/>
+            <a:off x="5257799" y="3145536"/>
+            <a:ext cx="1234440" cy="237744"/>
           </a:xfrm>
           <a:prstGeom prst="rect">
             <a:avLst/>
@@ -6631,7 +6632,7 @@
                 <a:latin typeface="微软雅黑"/>
                 <a:ea typeface="微软雅黑"/>
               </a:rPr>
-              <a:t>线框复刻。红=绘制，蓝=叠加，黄=送显。模块名按原图（含 windowManger 拼写）。</a:t>
+              <a:t>真机线框。红=绘制，蓝=叠加，黄=送显。模块名按原图（含 windowManger 拼写）。</a:t>
             </a:r>
           </a:p>
         </p:txBody>
@@ -7628,8 +7629,8 @@
         </p:nvSpPr>
         <p:spPr>
           <a:xfrm>
-            <a:off x="3246120" y="3520440"/>
-            <a:ext cx="1965960" cy="566928"/>
+            <a:off x="3246120" y="3401568"/>
+            <a:ext cx="1965960" cy="457200"/>
           </a:xfrm>
           <a:prstGeom prst="roundRect">
             <a:avLst>
@@ -7665,7 +7666,7 @@
           <a:p>
             <a:pPr algn="ctr"/>
             <a:r>
-              <a:rPr sz="1300" b="1">
+              <a:rPr sz="1200" b="1">
                 <a:solidFill>
                   <a:srgbClr val="C96C16"/>
                 </a:solidFill>
@@ -8824,7 +8825,7 @@
         <p:spPr>
           <a:xfrm>
             <a:off x="3223260" y="2770632"/>
-            <a:ext cx="1005840" cy="749808"/>
+            <a:ext cx="1005840" cy="630936"/>
           </a:xfrm>
           <a:prstGeom prst="line">
             <a:avLst/>
@@ -8860,7 +8861,7 @@
         <p:spPr>
           <a:xfrm flipH="1">
             <a:off x="4549140" y="2770632"/>
-            <a:ext cx="45720" cy="749808"/>
+            <a:ext cx="45720" cy="630936"/>
           </a:xfrm>
           <a:prstGeom prst="line">
             <a:avLst/>
@@ -8968,7 +8969,7 @@
         <p:spPr>
           <a:xfrm>
             <a:off x="5920740" y="2770632"/>
-            <a:ext cx="0" cy="1033272"/>
+            <a:ext cx="0" cy="859536"/>
           </a:xfrm>
           <a:prstGeom prst="line">
             <a:avLst/>
@@ -9002,7 +9003,7 @@
         </p:nvCxnSpPr>
         <p:spPr>
           <a:xfrm flipH="1">
-            <a:off x="5463540" y="3803904"/>
+            <a:off x="5463540" y="3630168"/>
             <a:ext cx="457200" cy="0"/>
           </a:xfrm>
           <a:prstGeom prst="line">
@@ -9037,8 +9038,8 @@
         </p:nvCxnSpPr>
         <p:spPr>
           <a:xfrm>
-            <a:off x="5463540" y="3803904"/>
-            <a:ext cx="0" cy="2185416"/>
+            <a:off x="5463540" y="3630168"/>
+            <a:ext cx="0" cy="2359152"/>
           </a:xfrm>
           <a:prstGeom prst="line">
             <a:avLst/>
@@ -9073,8 +9074,8 @@
         </p:nvCxnSpPr>
         <p:spPr>
           <a:xfrm>
-            <a:off x="4229100" y="4087368"/>
-            <a:ext cx="1234440" cy="1901952"/>
+            <a:off x="4229100" y="3858768"/>
+            <a:ext cx="1234440" cy="2130552"/>
           </a:xfrm>
           <a:prstGeom prst="line">
             <a:avLst/>
@@ -9397,7 +9398,7 @@
         </p:nvCxnSpPr>
         <p:spPr>
           <a:xfrm>
-            <a:off x="5212079" y="3803904"/>
+            <a:off x="5212079" y="3630168"/>
             <a:ext cx="1691641" cy="0"/>
           </a:xfrm>
           <a:prstGeom prst="line">
@@ -9433,8 +9434,8 @@
         </p:nvSpPr>
         <p:spPr>
           <a:xfrm>
-            <a:off x="5257799" y="3264408"/>
-            <a:ext cx="1005840" cy="237744"/>
+            <a:off x="5257799" y="3145536"/>
+            <a:ext cx="1234440" cy="237744"/>
           </a:xfrm>
           <a:prstGeom prst="rect">
             <a:avLst/>
@@ -10091,131 +10092,7 @@
       </p:sp>
       <p:sp>
         <p:nvSpPr>
-          <p:cNvPr id="83" name="Rounded Rectangle 82"/>
-          <p:cNvSpPr/>
-          <p:nvPr/>
-        </p:nvSpPr>
-        <p:spPr>
-          <a:xfrm>
-            <a:off x="91440" y="1783080"/>
-            <a:ext cx="1280160" cy="2788920"/>
-          </a:xfrm>
-          <a:prstGeom prst="roundRect">
-            <a:avLst>
-              <a:gd name="adj" fmla="val 8000"/>
-            </a:avLst>
-          </a:prstGeom>
-          <a:solidFill>
-            <a:srgbClr val="FFF3E0"/>
-          </a:solidFill>
-          <a:ln w="25400">
-            <a:solidFill>
-              <a:srgbClr val="C96C16"/>
-            </a:solidFill>
-          </a:ln>
-        </p:spPr>
-        <p:style>
-          <a:lnRef idx="1">
-            <a:schemeClr val="accent1"/>
-          </a:lnRef>
-          <a:fillRef idx="3">
-            <a:schemeClr val="accent1"/>
-          </a:fillRef>
-          <a:effectRef idx="2">
-            <a:schemeClr val="accent1"/>
-          </a:effectRef>
-          <a:fontRef idx="minor">
-            <a:schemeClr val="lt1"/>
-          </a:fontRef>
-        </p:style>
-        <p:txBody>
-          <a:bodyPr rtlCol="0" anchor="ctr" wrap="square"/>
-          <a:lstStyle/>
-          <a:p>
-            <a:pPr algn="ctr"/>
-            <a:r>
-              <a:rPr sz="1100" b="1">
-                <a:solidFill>
-                  <a:srgbClr val="C96C16"/>
-                </a:solidFill>
-                <a:latin typeface="微软雅黑"/>
-                <a:ea typeface="微软雅黑"/>
-              </a:rPr>
-              <a:t>SwiftShader
-落点
-Native 层
-Open GL ES
-的实现
-截断到 GPU
-的绘制红线
-HWUI / SF
-只是下单方</a:t>
-            </a:r>
-          </a:p>
-        </p:txBody>
-      </p:sp>
-      <p:sp>
-        <p:nvSpPr>
-          <p:cNvPr id="84" name="Rounded Rectangle 83"/>
-          <p:cNvSpPr/>
-          <p:nvPr/>
-        </p:nvSpPr>
-        <p:spPr>
-          <a:xfrm>
-            <a:off x="4764024" y="5952744"/>
-            <a:ext cx="1399032" cy="941832"/>
-          </a:xfrm>
-          <a:prstGeom prst="roundRect">
-            <a:avLst>
-              <a:gd name="adj" fmla="val 8000"/>
-            </a:avLst>
-          </a:prstGeom>
-          <a:solidFill>
-            <a:srgbClr val="F0F0F0"/>
-          </a:solidFill>
-          <a:ln w="19050">
-            <a:solidFill>
-              <a:srgbClr val="666666"/>
-            </a:solidFill>
-          </a:ln>
-        </p:spPr>
-        <p:style>
-          <a:lnRef idx="1">
-            <a:schemeClr val="accent1"/>
-          </a:lnRef>
-          <a:fillRef idx="3">
-            <a:schemeClr val="accent1"/>
-          </a:fillRef>
-          <a:effectRef idx="2">
-            <a:schemeClr val="accent1"/>
-          </a:effectRef>
-          <a:fontRef idx="minor">
-            <a:schemeClr val="lt1"/>
-          </a:fontRef>
-        </p:style>
-        <p:txBody>
-          <a:bodyPr rtlCol="0" anchor="ctr" wrap="square"/>
-          <a:lstStyle/>
-          <a:p>
-            <a:pPr algn="ctr"/>
-            <a:r>
-              <a:rPr sz="1000" b="1">
-                <a:solidFill>
-                  <a:srgbClr val="666666"/>
-                </a:solidFill>
-                <a:latin typeface="微软雅黑"/>
-                <a:ea typeface="微软雅黑"/>
-              </a:rPr>
-              <a:t>GPU
-真机才走
-本沙箱旁路</a:t>
-            </a:r>
-          </a:p>
-        </p:txBody>
-      </p:sp>
-      <p:sp>
-        <p:nvSpPr>
-          <p:cNvPr id="85" name="TextBox 84"/>
+          <p:cNvPr id="83" name="TextBox 82"/>
           <p:cNvSpPr txBox="1"/>
           <p:nvPr/>
         </p:nvSpPr>
@@ -10242,7 +10119,7 @@
                 <a:latin typeface="微软雅黑"/>
                 <a:ea typeface="微软雅黑"/>
               </a:rPr>
-              <a:t>SwiftShader = Native 层 OpenGL ES 的用户态实现，不是 Kernel GPU，也不是 SurfaceFlinger / HWC。SF 的 GPU 叠加同样打进这个 GLES 盒。</a:t>
+              <a:t>落点：Native 层 OpenGL ES 的实现。不是 Kernel GPU，也不是 SurfaceFlinger / HWC。</a:t>
             </a:r>
           </a:p>
         </p:txBody>
@@ -10256,6 +10133,3660 @@
 </file>
 
 <file path=ppt/slides/slide4.xml><?xml version="1.0" encoding="utf-8"?>
+<p:sld xmlns:a="http://schemas.openxmlformats.org/drawingml/2006/main" xmlns:p="http://schemas.openxmlformats.org/presentationml/2006/main" xmlns:r="http://schemas.openxmlformats.org/officeDocument/2006/relationships">
+  <p:cSld>
+    <p:spTree>
+      <p:nvGrpSpPr>
+        <p:cNvPr id="1" name=""/>
+        <p:cNvGrpSpPr/>
+        <p:nvPr/>
+      </p:nvGrpSpPr>
+      <p:grpSpPr/>
+      <p:sp>
+        <p:nvSpPr>
+          <p:cNvPr id="2" name="Rectangle 1"/>
+          <p:cNvSpPr/>
+          <p:nvPr/>
+        </p:nvSpPr>
+        <p:spPr>
+          <a:xfrm>
+            <a:off x="1417320" y="164592"/>
+            <a:ext cx="12938760" cy="347472"/>
+          </a:xfrm>
+          <a:prstGeom prst="rect">
+            <a:avLst/>
+          </a:prstGeom>
+          <a:solidFill>
+            <a:srgbClr val="F4F5F7"/>
+          </a:solidFill>
+          <a:ln w="15875">
+            <a:solidFill>
+              <a:srgbClr val="333333"/>
+            </a:solidFill>
+          </a:ln>
+        </p:spPr>
+        <p:style>
+          <a:lnRef idx="1">
+            <a:schemeClr val="accent1"/>
+          </a:lnRef>
+          <a:fillRef idx="3">
+            <a:schemeClr val="accent1"/>
+          </a:fillRef>
+          <a:effectRef idx="2">
+            <a:schemeClr val="accent1"/>
+          </a:effectRef>
+          <a:fontRef idx="minor">
+            <a:schemeClr val="lt1"/>
+          </a:fontRef>
+        </p:style>
+        <p:txBody>
+          <a:bodyPr rtlCol="0" anchor="ctr"/>
+          <a:lstStyle/>
+          <a:p>
+            <a:pPr algn="ctr"/>
+          </a:p>
+        </p:txBody>
+      </p:sp>
+      <p:sp>
+        <p:nvSpPr>
+          <p:cNvPr id="3" name="TextBox 2"/>
+          <p:cNvSpPr txBox="1"/>
+          <p:nvPr/>
+        </p:nvSpPr>
+        <p:spPr>
+          <a:xfrm>
+            <a:off x="1490472" y="182879"/>
+            <a:ext cx="2194560" cy="256032"/>
+          </a:xfrm>
+          <a:prstGeom prst="rect">
+            <a:avLst/>
+          </a:prstGeom>
+          <a:noFill/>
+        </p:spPr>
+        <p:txBody>
+          <a:bodyPr wrap="square" anchor="ctr"/>
+          <a:lstStyle/>
+          <a:p>
+            <a:pPr algn="l"/>
+            <a:r>
+              <a:rPr sz="1200" b="1">
+                <a:solidFill>
+                  <a:srgbClr val="162A5A"/>
+                </a:solidFill>
+                <a:latin typeface="微软雅黑"/>
+                <a:ea typeface="微软雅黑"/>
+              </a:rPr>
+              <a:t>APP（MicroVM 内 ReDroid）</a:t>
+            </a:r>
+          </a:p>
+        </p:txBody>
+      </p:sp>
+      <p:sp>
+        <p:nvSpPr>
+          <p:cNvPr id="4" name="Rectangle 3"/>
+          <p:cNvSpPr/>
+          <p:nvPr/>
+        </p:nvSpPr>
+        <p:spPr>
+          <a:xfrm>
+            <a:off x="1417320" y="512064"/>
+            <a:ext cx="12938760" cy="1024128"/>
+          </a:xfrm>
+          <a:prstGeom prst="rect">
+            <a:avLst/>
+          </a:prstGeom>
+          <a:solidFill>
+            <a:srgbClr val="F4F5F7"/>
+          </a:solidFill>
+          <a:ln w="15875">
+            <a:solidFill>
+              <a:srgbClr val="333333"/>
+            </a:solidFill>
+          </a:ln>
+        </p:spPr>
+        <p:style>
+          <a:lnRef idx="1">
+            <a:schemeClr val="accent1"/>
+          </a:lnRef>
+          <a:fillRef idx="3">
+            <a:schemeClr val="accent1"/>
+          </a:fillRef>
+          <a:effectRef idx="2">
+            <a:schemeClr val="accent1"/>
+          </a:effectRef>
+          <a:fontRef idx="minor">
+            <a:schemeClr val="lt1"/>
+          </a:fontRef>
+        </p:style>
+        <p:txBody>
+          <a:bodyPr rtlCol="0" anchor="ctr"/>
+          <a:lstStyle/>
+          <a:p>
+            <a:pPr algn="ctr"/>
+          </a:p>
+        </p:txBody>
+      </p:sp>
+      <p:sp>
+        <p:nvSpPr>
+          <p:cNvPr id="5" name="TextBox 4"/>
+          <p:cNvSpPr txBox="1"/>
+          <p:nvPr/>
+        </p:nvSpPr>
+        <p:spPr>
+          <a:xfrm>
+            <a:off x="1490472" y="530352"/>
+            <a:ext cx="2194560" cy="256032"/>
+          </a:xfrm>
+          <a:prstGeom prst="rect">
+            <a:avLst/>
+          </a:prstGeom>
+          <a:noFill/>
+        </p:spPr>
+        <p:txBody>
+          <a:bodyPr wrap="square" anchor="ctr"/>
+          <a:lstStyle/>
+          <a:p>
+            <a:pPr algn="l"/>
+            <a:r>
+              <a:rPr sz="1200" b="1">
+                <a:solidFill>
+                  <a:srgbClr val="162A5A"/>
+                </a:solidFill>
+                <a:latin typeface="微软雅黑"/>
+                <a:ea typeface="微软雅黑"/>
+              </a:rPr>
+              <a:t>Framework</a:t>
+            </a:r>
+          </a:p>
+        </p:txBody>
+      </p:sp>
+      <p:sp>
+        <p:nvSpPr>
+          <p:cNvPr id="6" name="Rectangle 5"/>
+          <p:cNvSpPr/>
+          <p:nvPr/>
+        </p:nvSpPr>
+        <p:spPr>
+          <a:xfrm>
+            <a:off x="1417320" y="1572768"/>
+            <a:ext cx="12938760" cy="3127248"/>
+          </a:xfrm>
+          <a:prstGeom prst="rect">
+            <a:avLst/>
+          </a:prstGeom>
+          <a:solidFill>
+            <a:srgbClr val="F4F5F7"/>
+          </a:solidFill>
+          <a:ln w="15875">
+            <a:solidFill>
+              <a:srgbClr val="333333"/>
+            </a:solidFill>
+          </a:ln>
+        </p:spPr>
+        <p:style>
+          <a:lnRef idx="1">
+            <a:schemeClr val="accent1"/>
+          </a:lnRef>
+          <a:fillRef idx="3">
+            <a:schemeClr val="accent1"/>
+          </a:fillRef>
+          <a:effectRef idx="2">
+            <a:schemeClr val="accent1"/>
+          </a:effectRef>
+          <a:fontRef idx="minor">
+            <a:schemeClr val="lt1"/>
+          </a:fontRef>
+        </p:style>
+        <p:txBody>
+          <a:bodyPr rtlCol="0" anchor="ctr"/>
+          <a:lstStyle/>
+          <a:p>
+            <a:pPr algn="ctr"/>
+          </a:p>
+        </p:txBody>
+      </p:sp>
+      <p:sp>
+        <p:nvSpPr>
+          <p:cNvPr id="7" name="TextBox 6"/>
+          <p:cNvSpPr txBox="1"/>
+          <p:nvPr/>
+        </p:nvSpPr>
+        <p:spPr>
+          <a:xfrm>
+            <a:off x="1490472" y="1591056"/>
+            <a:ext cx="2194560" cy="256032"/>
+          </a:xfrm>
+          <a:prstGeom prst="rect">
+            <a:avLst/>
+          </a:prstGeom>
+          <a:noFill/>
+        </p:spPr>
+        <p:txBody>
+          <a:bodyPr wrap="square" anchor="ctr"/>
+          <a:lstStyle/>
+          <a:p>
+            <a:pPr algn="l"/>
+            <a:r>
+              <a:rPr sz="1200" b="1">
+                <a:solidFill>
+                  <a:srgbClr val="162A5A"/>
+                </a:solidFill>
+                <a:latin typeface="微软雅黑"/>
+                <a:ea typeface="微软雅黑"/>
+              </a:rPr>
+              <a:t>Native</a:t>
+            </a:r>
+          </a:p>
+        </p:txBody>
+      </p:sp>
+      <p:sp>
+        <p:nvSpPr>
+          <p:cNvPr id="8" name="Rectangle 7"/>
+          <p:cNvSpPr/>
+          <p:nvPr/>
+        </p:nvSpPr>
+        <p:spPr>
+          <a:xfrm>
+            <a:off x="1417320" y="4736592"/>
+            <a:ext cx="12938760" cy="896112"/>
+          </a:xfrm>
+          <a:prstGeom prst="rect">
+            <a:avLst/>
+          </a:prstGeom>
+          <a:solidFill>
+            <a:srgbClr val="F4F5F7"/>
+          </a:solidFill>
+          <a:ln w="15875">
+            <a:solidFill>
+              <a:srgbClr val="333333"/>
+            </a:solidFill>
+          </a:ln>
+        </p:spPr>
+        <p:style>
+          <a:lnRef idx="1">
+            <a:schemeClr val="accent1"/>
+          </a:lnRef>
+          <a:fillRef idx="3">
+            <a:schemeClr val="accent1"/>
+          </a:fillRef>
+          <a:effectRef idx="2">
+            <a:schemeClr val="accent1"/>
+          </a:effectRef>
+          <a:fontRef idx="minor">
+            <a:schemeClr val="lt1"/>
+          </a:fontRef>
+        </p:style>
+        <p:txBody>
+          <a:bodyPr rtlCol="0" anchor="ctr"/>
+          <a:lstStyle/>
+          <a:p>
+            <a:pPr algn="ctr"/>
+          </a:p>
+        </p:txBody>
+      </p:sp>
+      <p:sp>
+        <p:nvSpPr>
+          <p:cNvPr id="9" name="TextBox 8"/>
+          <p:cNvSpPr txBox="1"/>
+          <p:nvPr/>
+        </p:nvSpPr>
+        <p:spPr>
+          <a:xfrm>
+            <a:off x="1490472" y="4754879"/>
+            <a:ext cx="2194560" cy="256032"/>
+          </a:xfrm>
+          <a:prstGeom prst="rect">
+            <a:avLst/>
+          </a:prstGeom>
+          <a:noFill/>
+        </p:spPr>
+        <p:txBody>
+          <a:bodyPr wrap="square" anchor="ctr"/>
+          <a:lstStyle/>
+          <a:p>
+            <a:pPr algn="l"/>
+            <a:r>
+              <a:rPr sz="1200" b="1">
+                <a:solidFill>
+                  <a:srgbClr val="162A5A"/>
+                </a:solidFill>
+                <a:latin typeface="微软雅黑"/>
+                <a:ea typeface="微软雅黑"/>
+              </a:rPr>
+              <a:t>HAL</a:t>
+            </a:r>
+          </a:p>
+        </p:txBody>
+      </p:sp>
+      <p:sp>
+        <p:nvSpPr>
+          <p:cNvPr id="10" name="Rectangle 9"/>
+          <p:cNvSpPr/>
+          <p:nvPr/>
+        </p:nvSpPr>
+        <p:spPr>
+          <a:xfrm>
+            <a:off x="1417320" y="5669280"/>
+            <a:ext cx="12938760" cy="2212848"/>
+          </a:xfrm>
+          <a:prstGeom prst="rect">
+            <a:avLst/>
+          </a:prstGeom>
+          <a:solidFill>
+            <a:srgbClr val="F4F5F7"/>
+          </a:solidFill>
+          <a:ln w="15875">
+            <a:solidFill>
+              <a:srgbClr val="333333"/>
+            </a:solidFill>
+          </a:ln>
+        </p:spPr>
+        <p:style>
+          <a:lnRef idx="1">
+            <a:schemeClr val="accent1"/>
+          </a:lnRef>
+          <a:fillRef idx="3">
+            <a:schemeClr val="accent1"/>
+          </a:fillRef>
+          <a:effectRef idx="2">
+            <a:schemeClr val="accent1"/>
+          </a:effectRef>
+          <a:fontRef idx="minor">
+            <a:schemeClr val="lt1"/>
+          </a:fontRef>
+        </p:style>
+        <p:txBody>
+          <a:bodyPr rtlCol="0" anchor="ctr"/>
+          <a:lstStyle/>
+          <a:p>
+            <a:pPr algn="ctr"/>
+          </a:p>
+        </p:txBody>
+      </p:sp>
+      <p:sp>
+        <p:nvSpPr>
+          <p:cNvPr id="11" name="TextBox 10"/>
+          <p:cNvSpPr txBox="1"/>
+          <p:nvPr/>
+        </p:nvSpPr>
+        <p:spPr>
+          <a:xfrm>
+            <a:off x="1490472" y="5687568"/>
+            <a:ext cx="2194560" cy="256032"/>
+          </a:xfrm>
+          <a:prstGeom prst="rect">
+            <a:avLst/>
+          </a:prstGeom>
+          <a:noFill/>
+        </p:spPr>
+        <p:txBody>
+          <a:bodyPr wrap="square" anchor="ctr"/>
+          <a:lstStyle/>
+          <a:p>
+            <a:pPr algn="l"/>
+            <a:r>
+              <a:rPr sz="1200" b="1">
+                <a:solidFill>
+                  <a:srgbClr val="162A5A"/>
+                </a:solidFill>
+                <a:latin typeface="微软雅黑"/>
+                <a:ea typeface="微软雅黑"/>
+              </a:rPr>
+              <a:t>Kernel</a:t>
+            </a:r>
+          </a:p>
+        </p:txBody>
+      </p:sp>
+      <p:sp>
+        <p:nvSpPr>
+          <p:cNvPr id="12" name="Rounded Rectangle 11"/>
+          <p:cNvSpPr/>
+          <p:nvPr/>
+        </p:nvSpPr>
+        <p:spPr>
+          <a:xfrm>
+            <a:off x="1874519" y="713232"/>
+            <a:ext cx="1325880" cy="566928"/>
+          </a:xfrm>
+          <a:prstGeom prst="roundRect">
+            <a:avLst>
+              <a:gd name="adj" fmla="val 8000"/>
+            </a:avLst>
+          </a:prstGeom>
+          <a:solidFill>
+            <a:srgbClr val="FFFFFF"/>
+          </a:solidFill>
+          <a:ln w="12700">
+            <a:solidFill>
+              <a:srgbClr val="222222"/>
+            </a:solidFill>
+          </a:ln>
+        </p:spPr>
+        <p:style>
+          <a:lnRef idx="1">
+            <a:schemeClr val="accent1"/>
+          </a:lnRef>
+          <a:fillRef idx="3">
+            <a:schemeClr val="accent1"/>
+          </a:fillRef>
+          <a:effectRef idx="2">
+            <a:schemeClr val="accent1"/>
+          </a:effectRef>
+          <a:fontRef idx="minor">
+            <a:schemeClr val="lt1"/>
+          </a:fontRef>
+        </p:style>
+        <p:txBody>
+          <a:bodyPr rtlCol="0" anchor="ctr" wrap="square"/>
+          <a:lstStyle/>
+          <a:p>
+            <a:pPr algn="ctr"/>
+            <a:r>
+              <a:rPr sz="1000" b="0">
+                <a:solidFill>
+                  <a:srgbClr val="222222"/>
+                </a:solidFill>
+                <a:latin typeface="微软雅黑"/>
+                <a:ea typeface="微软雅黑"/>
+              </a:rPr>
+              <a:t>Graphics
+控件</a:t>
+            </a:r>
+          </a:p>
+        </p:txBody>
+      </p:sp>
+      <p:sp>
+        <p:nvSpPr>
+          <p:cNvPr id="13" name="Rounded Rectangle 12"/>
+          <p:cNvSpPr/>
+          <p:nvPr/>
+        </p:nvSpPr>
+        <p:spPr>
+          <a:xfrm>
+            <a:off x="4160520" y="658368"/>
+            <a:ext cx="1417320" cy="566928"/>
+          </a:xfrm>
+          <a:prstGeom prst="roundRect">
+            <a:avLst>
+              <a:gd name="adj" fmla="val 8000"/>
+            </a:avLst>
+          </a:prstGeom>
+          <a:solidFill>
+            <a:srgbClr val="FFFFFF"/>
+          </a:solidFill>
+          <a:ln w="12700">
+            <a:solidFill>
+              <a:srgbClr val="222222"/>
+            </a:solidFill>
+          </a:ln>
+        </p:spPr>
+        <p:style>
+          <a:lnRef idx="1">
+            <a:schemeClr val="accent1"/>
+          </a:lnRef>
+          <a:fillRef idx="3">
+            <a:schemeClr val="accent1"/>
+          </a:fillRef>
+          <a:effectRef idx="2">
+            <a:schemeClr val="accent1"/>
+          </a:effectRef>
+          <a:fontRef idx="minor">
+            <a:schemeClr val="lt1"/>
+          </a:fontRef>
+        </p:style>
+        <p:txBody>
+          <a:bodyPr rtlCol="0" anchor="ctr" wrap="square"/>
+          <a:lstStyle/>
+          <a:p>
+            <a:pPr algn="ctr"/>
+            <a:r>
+              <a:rPr sz="1200" b="1">
+                <a:solidFill>
+                  <a:srgbClr val="222222"/>
+                </a:solidFill>
+                <a:latin typeface="微软雅黑"/>
+                <a:ea typeface="微软雅黑"/>
+              </a:rPr>
+              <a:t>Open GL</a:t>
+            </a:r>
+          </a:p>
+        </p:txBody>
+      </p:sp>
+      <p:sp>
+        <p:nvSpPr>
+          <p:cNvPr id="14" name="Rounded Rectangle 13"/>
+          <p:cNvSpPr/>
+          <p:nvPr/>
+        </p:nvSpPr>
+        <p:spPr>
+          <a:xfrm>
+            <a:off x="7818120" y="658368"/>
+            <a:ext cx="1783080" cy="566928"/>
+          </a:xfrm>
+          <a:prstGeom prst="roundRect">
+            <a:avLst>
+              <a:gd name="adj" fmla="val 8000"/>
+            </a:avLst>
+          </a:prstGeom>
+          <a:solidFill>
+            <a:srgbClr val="FFFFFF"/>
+          </a:solidFill>
+          <a:ln w="12700">
+            <a:solidFill>
+              <a:srgbClr val="222222"/>
+            </a:solidFill>
+          </a:ln>
+        </p:spPr>
+        <p:style>
+          <a:lnRef idx="1">
+            <a:schemeClr val="accent1"/>
+          </a:lnRef>
+          <a:fillRef idx="3">
+            <a:schemeClr val="accent1"/>
+          </a:fillRef>
+          <a:effectRef idx="2">
+            <a:schemeClr val="accent1"/>
+          </a:effectRef>
+          <a:fontRef idx="minor">
+            <a:schemeClr val="lt1"/>
+          </a:fontRef>
+        </p:style>
+        <p:txBody>
+          <a:bodyPr rtlCol="0" anchor="ctr" wrap="square"/>
+          <a:lstStyle/>
+          <a:p>
+            <a:pPr algn="ctr"/>
+            <a:r>
+              <a:rPr sz="1100" b="0">
+                <a:solidFill>
+                  <a:srgbClr val="222222"/>
+                </a:solidFill>
+                <a:latin typeface="微软雅黑"/>
+                <a:ea typeface="微软雅黑"/>
+              </a:rPr>
+              <a:t>windowManger</a:t>
+            </a:r>
+          </a:p>
+        </p:txBody>
+      </p:sp>
+      <p:sp>
+        <p:nvSpPr>
+          <p:cNvPr id="15" name="Rounded Rectangle 14"/>
+          <p:cNvSpPr/>
+          <p:nvPr/>
+        </p:nvSpPr>
+        <p:spPr>
+          <a:xfrm>
+            <a:off x="2331720" y="1783080"/>
+            <a:ext cx="6903720" cy="384048"/>
+          </a:xfrm>
+          <a:prstGeom prst="roundRect">
+            <a:avLst>
+              <a:gd name="adj" fmla="val 8000"/>
+            </a:avLst>
+          </a:prstGeom>
+          <a:solidFill>
+            <a:srgbClr val="FFFFFF"/>
+          </a:solidFill>
+          <a:ln w="12700">
+            <a:solidFill>
+              <a:srgbClr val="222222"/>
+            </a:solidFill>
+          </a:ln>
+        </p:spPr>
+        <p:style>
+          <a:lnRef idx="1">
+            <a:schemeClr val="accent1"/>
+          </a:lnRef>
+          <a:fillRef idx="3">
+            <a:schemeClr val="accent1"/>
+          </a:fillRef>
+          <a:effectRef idx="2">
+            <a:schemeClr val="accent1"/>
+          </a:effectRef>
+          <a:fontRef idx="minor">
+            <a:schemeClr val="lt1"/>
+          </a:fontRef>
+        </p:style>
+        <p:txBody>
+          <a:bodyPr rtlCol="0" anchor="ctr" wrap="square"/>
+          <a:lstStyle/>
+          <a:p>
+            <a:pPr algn="ctr"/>
+            <a:r>
+              <a:rPr sz="1200" b="1">
+                <a:solidFill>
+                  <a:srgbClr val="222222"/>
+                </a:solidFill>
+                <a:latin typeface="微软雅黑"/>
+                <a:ea typeface="微软雅黑"/>
+              </a:rPr>
+              <a:t>libandroid_runtime</a:t>
+            </a:r>
+          </a:p>
+        </p:txBody>
+      </p:sp>
+      <p:sp>
+        <p:nvSpPr>
+          <p:cNvPr id="16" name="Rounded Rectangle 15"/>
+          <p:cNvSpPr/>
+          <p:nvPr/>
+        </p:nvSpPr>
+        <p:spPr>
+          <a:xfrm>
+            <a:off x="2606040" y="2331720"/>
+            <a:ext cx="1234440" cy="438912"/>
+          </a:xfrm>
+          <a:prstGeom prst="roundRect">
+            <a:avLst>
+              <a:gd name="adj" fmla="val 8000"/>
+            </a:avLst>
+          </a:prstGeom>
+          <a:solidFill>
+            <a:srgbClr val="FFFFFF"/>
+          </a:solidFill>
+          <a:ln w="12700">
+            <a:solidFill>
+              <a:srgbClr val="222222"/>
+            </a:solidFill>
+          </a:ln>
+        </p:spPr>
+        <p:style>
+          <a:lnRef idx="1">
+            <a:schemeClr val="accent1"/>
+          </a:lnRef>
+          <a:fillRef idx="3">
+            <a:schemeClr val="accent1"/>
+          </a:fillRef>
+          <a:effectRef idx="2">
+            <a:schemeClr val="accent1"/>
+          </a:effectRef>
+          <a:fontRef idx="minor">
+            <a:schemeClr val="lt1"/>
+          </a:fontRef>
+        </p:style>
+        <p:txBody>
+          <a:bodyPr rtlCol="0" anchor="ctr" wrap="square"/>
+          <a:lstStyle/>
+          <a:p>
+            <a:pPr algn="ctr"/>
+            <a:r>
+              <a:rPr sz="1200" b="1">
+                <a:solidFill>
+                  <a:srgbClr val="222222"/>
+                </a:solidFill>
+                <a:latin typeface="微软雅黑"/>
+                <a:ea typeface="微软雅黑"/>
+              </a:rPr>
+              <a:t>HWUI</a:t>
+            </a:r>
+          </a:p>
+        </p:txBody>
+      </p:sp>
+      <p:sp>
+        <p:nvSpPr>
+          <p:cNvPr id="17" name="Rounded Rectangle 16"/>
+          <p:cNvSpPr/>
+          <p:nvPr/>
+        </p:nvSpPr>
+        <p:spPr>
+          <a:xfrm>
+            <a:off x="4023360" y="2331720"/>
+            <a:ext cx="1143000" cy="438912"/>
+          </a:xfrm>
+          <a:prstGeom prst="roundRect">
+            <a:avLst>
+              <a:gd name="adj" fmla="val 8000"/>
+            </a:avLst>
+          </a:prstGeom>
+          <a:solidFill>
+            <a:srgbClr val="FFFFFF"/>
+          </a:solidFill>
+          <a:ln w="12700">
+            <a:solidFill>
+              <a:srgbClr val="222222"/>
+            </a:solidFill>
+          </a:ln>
+        </p:spPr>
+        <p:style>
+          <a:lnRef idx="1">
+            <a:schemeClr val="accent1"/>
+          </a:lnRef>
+          <a:fillRef idx="3">
+            <a:schemeClr val="accent1"/>
+          </a:fillRef>
+          <a:effectRef idx="2">
+            <a:schemeClr val="accent1"/>
+          </a:effectRef>
+          <a:fontRef idx="minor">
+            <a:schemeClr val="lt1"/>
+          </a:fontRef>
+        </p:style>
+        <p:txBody>
+          <a:bodyPr rtlCol="0" anchor="ctr" wrap="square"/>
+          <a:lstStyle/>
+          <a:p>
+            <a:pPr algn="ctr"/>
+            <a:r>
+              <a:rPr sz="1200" b="1">
+                <a:solidFill>
+                  <a:srgbClr val="222222"/>
+                </a:solidFill>
+                <a:latin typeface="微软雅黑"/>
+                <a:ea typeface="微软雅黑"/>
+              </a:rPr>
+              <a:t>libRS</a:t>
+            </a:r>
+          </a:p>
+        </p:txBody>
+      </p:sp>
+      <p:sp>
+        <p:nvSpPr>
+          <p:cNvPr id="18" name="Rounded Rectangle 17"/>
+          <p:cNvSpPr/>
+          <p:nvPr/>
+        </p:nvSpPr>
+        <p:spPr>
+          <a:xfrm>
+            <a:off x="5349240" y="2331720"/>
+            <a:ext cx="1143000" cy="438912"/>
+          </a:xfrm>
+          <a:prstGeom prst="roundRect">
+            <a:avLst>
+              <a:gd name="adj" fmla="val 8000"/>
+            </a:avLst>
+          </a:prstGeom>
+          <a:solidFill>
+            <a:srgbClr val="FFFFFF"/>
+          </a:solidFill>
+          <a:ln w="12700">
+            <a:solidFill>
+              <a:srgbClr val="222222"/>
+            </a:solidFill>
+          </a:ln>
+        </p:spPr>
+        <p:style>
+          <a:lnRef idx="1">
+            <a:schemeClr val="accent1"/>
+          </a:lnRef>
+          <a:fillRef idx="3">
+            <a:schemeClr val="accent1"/>
+          </a:fillRef>
+          <a:effectRef idx="2">
+            <a:schemeClr val="accent1"/>
+          </a:effectRef>
+          <a:fontRef idx="minor">
+            <a:schemeClr val="lt1"/>
+          </a:fontRef>
+        </p:style>
+        <p:txBody>
+          <a:bodyPr rtlCol="0" anchor="ctr" wrap="square"/>
+          <a:lstStyle/>
+          <a:p>
+            <a:pPr algn="ctr"/>
+            <a:r>
+              <a:rPr sz="1200" b="1">
+                <a:solidFill>
+                  <a:srgbClr val="222222"/>
+                </a:solidFill>
+                <a:latin typeface="微软雅黑"/>
+                <a:ea typeface="微软雅黑"/>
+              </a:rPr>
+              <a:t>Vulkan</a:t>
+            </a:r>
+          </a:p>
+        </p:txBody>
+      </p:sp>
+      <p:sp>
+        <p:nvSpPr>
+          <p:cNvPr id="19" name="Rounded Rectangle 18"/>
+          <p:cNvSpPr/>
+          <p:nvPr/>
+        </p:nvSpPr>
+        <p:spPr>
+          <a:xfrm>
+            <a:off x="7315200" y="2331720"/>
+            <a:ext cx="1325880" cy="438912"/>
+          </a:xfrm>
+          <a:prstGeom prst="roundRect">
+            <a:avLst>
+              <a:gd name="adj" fmla="val 8000"/>
+            </a:avLst>
+          </a:prstGeom>
+          <a:solidFill>
+            <a:srgbClr val="FFFFFF"/>
+          </a:solidFill>
+          <a:ln w="12700">
+            <a:solidFill>
+              <a:srgbClr val="222222"/>
+            </a:solidFill>
+          </a:ln>
+        </p:spPr>
+        <p:style>
+          <a:lnRef idx="1">
+            <a:schemeClr val="accent1"/>
+          </a:lnRef>
+          <a:fillRef idx="3">
+            <a:schemeClr val="accent1"/>
+          </a:fillRef>
+          <a:effectRef idx="2">
+            <a:schemeClr val="accent1"/>
+          </a:effectRef>
+          <a:fontRef idx="minor">
+            <a:schemeClr val="lt1"/>
+          </a:fontRef>
+        </p:style>
+        <p:txBody>
+          <a:bodyPr rtlCol="0" anchor="ctr" wrap="square"/>
+          <a:lstStyle/>
+          <a:p>
+            <a:pPr algn="ctr"/>
+            <a:r>
+              <a:rPr sz="1200" b="1">
+                <a:solidFill>
+                  <a:srgbClr val="222222"/>
+                </a:solidFill>
+                <a:latin typeface="微软雅黑"/>
+                <a:ea typeface="微软雅黑"/>
+              </a:rPr>
+              <a:t>libgui</a:t>
+            </a:r>
+          </a:p>
+        </p:txBody>
+      </p:sp>
+      <p:sp>
+        <p:nvSpPr>
+          <p:cNvPr id="20" name="Rounded Rectangle 19"/>
+          <p:cNvSpPr/>
+          <p:nvPr/>
+        </p:nvSpPr>
+        <p:spPr>
+          <a:xfrm>
+            <a:off x="11292840" y="2212848"/>
+            <a:ext cx="1874519" cy="566928"/>
+          </a:xfrm>
+          <a:prstGeom prst="roundRect">
+            <a:avLst>
+              <a:gd name="adj" fmla="val 8000"/>
+            </a:avLst>
+          </a:prstGeom>
+          <a:solidFill>
+            <a:srgbClr val="FFFFFF"/>
+          </a:solidFill>
+          <a:ln w="12700">
+            <a:solidFill>
+              <a:srgbClr val="222222"/>
+            </a:solidFill>
+          </a:ln>
+        </p:spPr>
+        <p:style>
+          <a:lnRef idx="1">
+            <a:schemeClr val="accent1"/>
+          </a:lnRef>
+          <a:fillRef idx="3">
+            <a:schemeClr val="accent1"/>
+          </a:fillRef>
+          <a:effectRef idx="2">
+            <a:schemeClr val="accent1"/>
+          </a:effectRef>
+          <a:fontRef idx="minor">
+            <a:schemeClr val="lt1"/>
+          </a:fontRef>
+        </p:style>
+        <p:txBody>
+          <a:bodyPr rtlCol="0" anchor="ctr" wrap="square"/>
+          <a:lstStyle/>
+          <a:p>
+            <a:pPr algn="ctr"/>
+            <a:r>
+              <a:rPr sz="1200" b="1">
+                <a:solidFill>
+                  <a:srgbClr val="222222"/>
+                </a:solidFill>
+                <a:latin typeface="微软雅黑"/>
+                <a:ea typeface="微软雅黑"/>
+              </a:rPr>
+              <a:t>MediaCodec</a:t>
+            </a:r>
+          </a:p>
+        </p:txBody>
+      </p:sp>
+      <p:sp>
+        <p:nvSpPr>
+          <p:cNvPr id="21" name="Rounded Rectangle 20"/>
+          <p:cNvSpPr/>
+          <p:nvPr/>
+        </p:nvSpPr>
+        <p:spPr>
+          <a:xfrm>
+            <a:off x="1691640" y="2944368"/>
+            <a:ext cx="1143000" cy="438912"/>
+          </a:xfrm>
+          <a:prstGeom prst="roundRect">
+            <a:avLst>
+              <a:gd name="adj" fmla="val 8000"/>
+            </a:avLst>
+          </a:prstGeom>
+          <a:solidFill>
+            <a:srgbClr val="FFFFFF"/>
+          </a:solidFill>
+          <a:ln w="12700">
+            <a:solidFill>
+              <a:srgbClr val="222222"/>
+            </a:solidFill>
+          </a:ln>
+        </p:spPr>
+        <p:style>
+          <a:lnRef idx="1">
+            <a:schemeClr val="accent1"/>
+          </a:lnRef>
+          <a:fillRef idx="3">
+            <a:schemeClr val="accent1"/>
+          </a:fillRef>
+          <a:effectRef idx="2">
+            <a:schemeClr val="accent1"/>
+          </a:effectRef>
+          <a:fontRef idx="minor">
+            <a:schemeClr val="lt1"/>
+          </a:fontRef>
+        </p:style>
+        <p:txBody>
+          <a:bodyPr rtlCol="0" anchor="ctr" wrap="square"/>
+          <a:lstStyle/>
+          <a:p>
+            <a:pPr algn="ctr"/>
+            <a:r>
+              <a:rPr sz="1200" b="1">
+                <a:solidFill>
+                  <a:srgbClr val="222222"/>
+                </a:solidFill>
+                <a:latin typeface="微软雅黑"/>
+                <a:ea typeface="微软雅黑"/>
+              </a:rPr>
+              <a:t>Skia</a:t>
+            </a:r>
+          </a:p>
+        </p:txBody>
+      </p:sp>
+      <p:sp>
+        <p:nvSpPr>
+          <p:cNvPr id="22" name="Rounded Rectangle 21"/>
+          <p:cNvSpPr/>
+          <p:nvPr/>
+        </p:nvSpPr>
+        <p:spPr>
+          <a:xfrm>
+            <a:off x="3246120" y="3401568"/>
+            <a:ext cx="1965960" cy="457200"/>
+          </a:xfrm>
+          <a:prstGeom prst="roundRect">
+            <a:avLst>
+              <a:gd name="adj" fmla="val 8000"/>
+            </a:avLst>
+          </a:prstGeom>
+          <a:solidFill>
+            <a:srgbClr val="FFF3E0"/>
+          </a:solidFill>
+          <a:ln w="28575">
+            <a:solidFill>
+              <a:srgbClr val="C96C16"/>
+            </a:solidFill>
+          </a:ln>
+        </p:spPr>
+        <p:style>
+          <a:lnRef idx="1">
+            <a:schemeClr val="accent1"/>
+          </a:lnRef>
+          <a:fillRef idx="3">
+            <a:schemeClr val="accent1"/>
+          </a:fillRef>
+          <a:effectRef idx="2">
+            <a:schemeClr val="accent1"/>
+          </a:effectRef>
+          <a:fontRef idx="minor">
+            <a:schemeClr val="lt1"/>
+          </a:fontRef>
+        </p:style>
+        <p:txBody>
+          <a:bodyPr rtlCol="0" anchor="ctr" wrap="square"/>
+          <a:lstStyle/>
+          <a:p>
+            <a:pPr algn="ctr"/>
+            <a:r>
+              <a:rPr sz="1200" b="1">
+                <a:solidFill>
+                  <a:srgbClr val="C96C16"/>
+                </a:solidFill>
+                <a:latin typeface="微软雅黑"/>
+                <a:ea typeface="微软雅黑"/>
+              </a:rPr>
+              <a:t>Open GL ES
+API</a:t>
+            </a:r>
+          </a:p>
+        </p:txBody>
+      </p:sp>
+      <p:sp>
+        <p:nvSpPr>
+          <p:cNvPr id="23" name="Rounded Rectangle 22"/>
+          <p:cNvSpPr/>
+          <p:nvPr/>
+        </p:nvSpPr>
+        <p:spPr>
+          <a:xfrm>
+            <a:off x="3108960" y="4096512"/>
+            <a:ext cx="2286000" cy="530352"/>
+          </a:xfrm>
+          <a:prstGeom prst="roundRect">
+            <a:avLst>
+              <a:gd name="adj" fmla="val 8000"/>
+            </a:avLst>
+          </a:prstGeom>
+          <a:solidFill>
+            <a:srgbClr val="FFF3E0"/>
+          </a:solidFill>
+          <a:ln w="28575">
+            <a:solidFill>
+              <a:srgbClr val="C96C16"/>
+            </a:solidFill>
+          </a:ln>
+        </p:spPr>
+        <p:style>
+          <a:lnRef idx="1">
+            <a:schemeClr val="accent1"/>
+          </a:lnRef>
+          <a:fillRef idx="3">
+            <a:schemeClr val="accent1"/>
+          </a:fillRef>
+          <a:effectRef idx="2">
+            <a:schemeClr val="accent1"/>
+          </a:effectRef>
+          <a:fontRef idx="minor">
+            <a:schemeClr val="lt1"/>
+          </a:fontRef>
+        </p:style>
+        <p:txBody>
+          <a:bodyPr rtlCol="0" anchor="ctr" wrap="square"/>
+          <a:lstStyle/>
+          <a:p>
+            <a:pPr algn="ctr"/>
+            <a:r>
+              <a:rPr sz="1200" b="1">
+                <a:solidFill>
+                  <a:srgbClr val="C96C16"/>
+                </a:solidFill>
+                <a:latin typeface="微软雅黑"/>
+                <a:ea typeface="微软雅黑"/>
+              </a:rPr>
+              <a:t>SwiftShader
+CPU 实现 GLES</a:t>
+            </a:r>
+          </a:p>
+        </p:txBody>
+      </p:sp>
+      <p:sp>
+        <p:nvSpPr>
+          <p:cNvPr id="24" name="Rounded Rectangle 23"/>
+          <p:cNvSpPr/>
+          <p:nvPr/>
+        </p:nvSpPr>
+        <p:spPr>
+          <a:xfrm>
+            <a:off x="7452360" y="2907792"/>
+            <a:ext cx="2148840" cy="475488"/>
+          </a:xfrm>
+          <a:prstGeom prst="roundRect">
+            <a:avLst>
+              <a:gd name="adj" fmla="val 8000"/>
+            </a:avLst>
+          </a:prstGeom>
+          <a:solidFill>
+            <a:srgbClr val="FFFFFF"/>
+          </a:solidFill>
+          <a:ln w="12700">
+            <a:solidFill>
+              <a:srgbClr val="222222"/>
+            </a:solidFill>
+          </a:ln>
+        </p:spPr>
+        <p:style>
+          <a:lnRef idx="1">
+            <a:schemeClr val="accent1"/>
+          </a:lnRef>
+          <a:fillRef idx="3">
+            <a:schemeClr val="accent1"/>
+          </a:fillRef>
+          <a:effectRef idx="2">
+            <a:schemeClr val="accent1"/>
+          </a:effectRef>
+          <a:fontRef idx="minor">
+            <a:schemeClr val="lt1"/>
+          </a:fontRef>
+        </p:style>
+        <p:txBody>
+          <a:bodyPr rtlCol="0" anchor="ctr" wrap="square"/>
+          <a:lstStyle/>
+          <a:p>
+            <a:pPr algn="ctr"/>
+            <a:r>
+              <a:rPr sz="1200" b="1">
+                <a:solidFill>
+                  <a:srgbClr val="222222"/>
+                </a:solidFill>
+                <a:latin typeface="微软雅黑"/>
+                <a:ea typeface="微软雅黑"/>
+              </a:rPr>
+              <a:t>SurfaceFlinger</a:t>
+            </a:r>
+          </a:p>
+        </p:txBody>
+      </p:sp>
+      <p:sp>
+        <p:nvSpPr>
+          <p:cNvPr id="25" name="Rounded Rectangle 24"/>
+          <p:cNvSpPr/>
+          <p:nvPr/>
+        </p:nvSpPr>
+        <p:spPr>
+          <a:xfrm>
+            <a:off x="6903720" y="3703320"/>
+            <a:ext cx="1783080" cy="502920"/>
+          </a:xfrm>
+          <a:prstGeom prst="roundRect">
+            <a:avLst>
+              <a:gd name="adj" fmla="val 8000"/>
+            </a:avLst>
+          </a:prstGeom>
+          <a:solidFill>
+            <a:srgbClr val="FFFFFF"/>
+          </a:solidFill>
+          <a:ln w="12700">
+            <a:solidFill>
+              <a:srgbClr val="222222"/>
+            </a:solidFill>
+          </a:ln>
+        </p:spPr>
+        <p:style>
+          <a:lnRef idx="1">
+            <a:schemeClr val="accent1"/>
+          </a:lnRef>
+          <a:fillRef idx="3">
+            <a:schemeClr val="accent1"/>
+          </a:fillRef>
+          <a:effectRef idx="2">
+            <a:schemeClr val="accent1"/>
+          </a:effectRef>
+          <a:fontRef idx="minor">
+            <a:schemeClr val="lt1"/>
+          </a:fontRef>
+        </p:style>
+        <p:txBody>
+          <a:bodyPr rtlCol="0" anchor="ctr" wrap="square"/>
+          <a:lstStyle/>
+          <a:p>
+            <a:pPr algn="ctr"/>
+            <a:r>
+              <a:rPr sz="1000" b="0">
+                <a:solidFill>
+                  <a:srgbClr val="222222"/>
+                </a:solidFill>
+                <a:latin typeface="微软雅黑"/>
+                <a:ea typeface="微软雅黑"/>
+              </a:rPr>
+              <a:t>allocator
+service</a:t>
+            </a:r>
+          </a:p>
+        </p:txBody>
+      </p:sp>
+      <p:sp>
+        <p:nvSpPr>
+          <p:cNvPr id="26" name="Rounded Rectangle 25"/>
+          <p:cNvSpPr/>
+          <p:nvPr/>
+        </p:nvSpPr>
+        <p:spPr>
+          <a:xfrm>
+            <a:off x="9006840" y="3703320"/>
+            <a:ext cx="1965960" cy="502920"/>
+          </a:xfrm>
+          <a:prstGeom prst="roundRect">
+            <a:avLst>
+              <a:gd name="adj" fmla="val 8000"/>
+            </a:avLst>
+          </a:prstGeom>
+          <a:solidFill>
+            <a:srgbClr val="FFFFFF"/>
+          </a:solidFill>
+          <a:ln w="12700">
+            <a:solidFill>
+              <a:srgbClr val="222222"/>
+            </a:solidFill>
+          </a:ln>
+        </p:spPr>
+        <p:style>
+          <a:lnRef idx="1">
+            <a:schemeClr val="accent1"/>
+          </a:lnRef>
+          <a:fillRef idx="3">
+            <a:schemeClr val="accent1"/>
+          </a:fillRef>
+          <a:effectRef idx="2">
+            <a:schemeClr val="accent1"/>
+          </a:effectRef>
+          <a:fontRef idx="minor">
+            <a:schemeClr val="lt1"/>
+          </a:fontRef>
+        </p:style>
+        <p:txBody>
+          <a:bodyPr rtlCol="0" anchor="ctr" wrap="square"/>
+          <a:lstStyle/>
+          <a:p>
+            <a:pPr algn="ctr"/>
+            <a:r>
+              <a:rPr sz="1000" b="0">
+                <a:solidFill>
+                  <a:srgbClr val="222222"/>
+                </a:solidFill>
+                <a:latin typeface="微软雅黑"/>
+                <a:ea typeface="微软雅黑"/>
+              </a:rPr>
+              <a:t>HWComposer
+service</a:t>
+            </a:r>
+          </a:p>
+        </p:txBody>
+      </p:sp>
+      <p:sp>
+        <p:nvSpPr>
+          <p:cNvPr id="27" name="Rounded Rectangle 26"/>
+          <p:cNvSpPr/>
+          <p:nvPr/>
+        </p:nvSpPr>
+        <p:spPr>
+          <a:xfrm>
+            <a:off x="7086600" y="4919472"/>
+            <a:ext cx="1417320" cy="502920"/>
+          </a:xfrm>
+          <a:prstGeom prst="roundRect">
+            <a:avLst>
+              <a:gd name="adj" fmla="val 8000"/>
+            </a:avLst>
+          </a:prstGeom>
+          <a:solidFill>
+            <a:srgbClr val="FFFFFF"/>
+          </a:solidFill>
+          <a:ln w="12700">
+            <a:solidFill>
+              <a:srgbClr val="222222"/>
+            </a:solidFill>
+          </a:ln>
+        </p:spPr>
+        <p:style>
+          <a:lnRef idx="1">
+            <a:schemeClr val="accent1"/>
+          </a:lnRef>
+          <a:fillRef idx="3">
+            <a:schemeClr val="accent1"/>
+          </a:fillRef>
+          <a:effectRef idx="2">
+            <a:schemeClr val="accent1"/>
+          </a:effectRef>
+          <a:fontRef idx="minor">
+            <a:schemeClr val="lt1"/>
+          </a:fontRef>
+        </p:style>
+        <p:txBody>
+          <a:bodyPr rtlCol="0" anchor="ctr" wrap="square"/>
+          <a:lstStyle/>
+          <a:p>
+            <a:pPr algn="ctr"/>
+            <a:r>
+              <a:rPr sz="1200" b="1">
+                <a:solidFill>
+                  <a:srgbClr val="222222"/>
+                </a:solidFill>
+                <a:latin typeface="微软雅黑"/>
+                <a:ea typeface="微软雅黑"/>
+              </a:rPr>
+              <a:t>Gralloc</a:t>
+            </a:r>
+          </a:p>
+        </p:txBody>
+      </p:sp>
+      <p:sp>
+        <p:nvSpPr>
+          <p:cNvPr id="28" name="Rounded Rectangle 27"/>
+          <p:cNvSpPr/>
+          <p:nvPr/>
+        </p:nvSpPr>
+        <p:spPr>
+          <a:xfrm>
+            <a:off x="9189720" y="4919472"/>
+            <a:ext cx="1325880" cy="502920"/>
+          </a:xfrm>
+          <a:prstGeom prst="roundRect">
+            <a:avLst>
+              <a:gd name="adj" fmla="val 8000"/>
+            </a:avLst>
+          </a:prstGeom>
+          <a:solidFill>
+            <a:srgbClr val="EEEEEE"/>
+          </a:solidFill>
+          <a:ln w="12700">
+            <a:solidFill>
+              <a:srgbClr val="666666"/>
+            </a:solidFill>
+          </a:ln>
+        </p:spPr>
+        <p:style>
+          <a:lnRef idx="1">
+            <a:schemeClr val="accent1"/>
+          </a:lnRef>
+          <a:fillRef idx="3">
+            <a:schemeClr val="accent1"/>
+          </a:fillRef>
+          <a:effectRef idx="2">
+            <a:schemeClr val="accent1"/>
+          </a:effectRef>
+          <a:fontRef idx="minor">
+            <a:schemeClr val="lt1"/>
+          </a:fontRef>
+        </p:style>
+        <p:txBody>
+          <a:bodyPr rtlCol="0" anchor="ctr" wrap="square"/>
+          <a:lstStyle/>
+          <a:p>
+            <a:pPr algn="ctr"/>
+            <a:r>
+              <a:rPr sz="1100" b="1">
+                <a:solidFill>
+                  <a:srgbClr val="666666"/>
+                </a:solidFill>
+                <a:latin typeface="微软雅黑"/>
+                <a:ea typeface="微软雅黑"/>
+              </a:rPr>
+              <a:t>HWC
+guest 弱</a:t>
+            </a:r>
+          </a:p>
+        </p:txBody>
+      </p:sp>
+      <p:sp>
+        <p:nvSpPr>
+          <p:cNvPr id="29" name="Rounded Rectangle 28"/>
+          <p:cNvSpPr/>
+          <p:nvPr/>
+        </p:nvSpPr>
+        <p:spPr>
+          <a:xfrm>
+            <a:off x="11018520" y="4919472"/>
+            <a:ext cx="1325880" cy="502920"/>
+          </a:xfrm>
+          <a:prstGeom prst="roundRect">
+            <a:avLst>
+              <a:gd name="adj" fmla="val 8000"/>
+            </a:avLst>
+          </a:prstGeom>
+          <a:solidFill>
+            <a:srgbClr val="EEEEEE"/>
+          </a:solidFill>
+          <a:ln w="12700">
+            <a:solidFill>
+              <a:srgbClr val="666666"/>
+            </a:solidFill>
+          </a:ln>
+        </p:spPr>
+        <p:style>
+          <a:lnRef idx="1">
+            <a:schemeClr val="accent1"/>
+          </a:lnRef>
+          <a:fillRef idx="3">
+            <a:schemeClr val="accent1"/>
+          </a:fillRef>
+          <a:effectRef idx="2">
+            <a:schemeClr val="accent1"/>
+          </a:effectRef>
+          <a:fontRef idx="minor">
+            <a:schemeClr val="lt1"/>
+          </a:fontRef>
+        </p:style>
+        <p:txBody>
+          <a:bodyPr rtlCol="0" anchor="ctr" wrap="square"/>
+          <a:lstStyle/>
+          <a:p>
+            <a:pPr algn="ctr"/>
+            <a:r>
+              <a:rPr sz="1200" b="1">
+                <a:solidFill>
+                  <a:srgbClr val="666666"/>
+                </a:solidFill>
+                <a:latin typeface="微软雅黑"/>
+                <a:ea typeface="微软雅黑"/>
+              </a:rPr>
+              <a:t>overlay</a:t>
+            </a:r>
+          </a:p>
+        </p:txBody>
+      </p:sp>
+      <p:sp>
+        <p:nvSpPr>
+          <p:cNvPr id="30" name="Rounded Rectangle 29"/>
+          <p:cNvSpPr/>
+          <p:nvPr/>
+        </p:nvSpPr>
+        <p:spPr>
+          <a:xfrm>
+            <a:off x="1691640" y="5989320"/>
+            <a:ext cx="1325880" cy="868680"/>
+          </a:xfrm>
+          <a:prstGeom prst="roundRect">
+            <a:avLst>
+              <a:gd name="adj" fmla="val 8000"/>
+            </a:avLst>
+          </a:prstGeom>
+          <a:solidFill>
+            <a:srgbClr val="EEEEEE"/>
+          </a:solidFill>
+          <a:ln w="12700">
+            <a:solidFill>
+              <a:srgbClr val="666666"/>
+            </a:solidFill>
+          </a:ln>
+        </p:spPr>
+        <p:style>
+          <a:lnRef idx="1">
+            <a:schemeClr val="accent1"/>
+          </a:lnRef>
+          <a:fillRef idx="3">
+            <a:schemeClr val="accent1"/>
+          </a:fillRef>
+          <a:effectRef idx="2">
+            <a:schemeClr val="accent1"/>
+          </a:effectRef>
+          <a:fontRef idx="minor">
+            <a:schemeClr val="lt1"/>
+          </a:fontRef>
+        </p:style>
+        <p:txBody>
+          <a:bodyPr rtlCol="0" anchor="ctr" wrap="square"/>
+          <a:lstStyle/>
+          <a:p>
+            <a:pPr algn="ctr"/>
+            <a:r>
+              <a:rPr sz="1000" b="0">
+                <a:solidFill>
+                  <a:srgbClr val="666666"/>
+                </a:solidFill>
+                <a:latin typeface="微软雅黑"/>
+                <a:ea typeface="微软雅黑"/>
+              </a:rPr>
+              <a:t>JPEG
+硬解加速
+（可选）</a:t>
+            </a:r>
+          </a:p>
+        </p:txBody>
+      </p:sp>
+      <p:sp>
+        <p:nvSpPr>
+          <p:cNvPr id="31" name="Rounded Rectangle 30"/>
+          <p:cNvSpPr/>
+          <p:nvPr/>
+        </p:nvSpPr>
+        <p:spPr>
+          <a:xfrm>
+            <a:off x="3154680" y="5989320"/>
+            <a:ext cx="1325880" cy="868680"/>
+          </a:xfrm>
+          <a:prstGeom prst="roundRect">
+            <a:avLst>
+              <a:gd name="adj" fmla="val 8000"/>
+            </a:avLst>
+          </a:prstGeom>
+          <a:solidFill>
+            <a:srgbClr val="EEEEEE"/>
+          </a:solidFill>
+          <a:ln w="12700">
+            <a:solidFill>
+              <a:srgbClr val="666666"/>
+            </a:solidFill>
+          </a:ln>
+        </p:spPr>
+        <p:style>
+          <a:lnRef idx="1">
+            <a:schemeClr val="accent1"/>
+          </a:lnRef>
+          <a:fillRef idx="3">
+            <a:schemeClr val="accent1"/>
+          </a:fillRef>
+          <a:effectRef idx="2">
+            <a:schemeClr val="accent1"/>
+          </a:effectRef>
+          <a:fontRef idx="minor">
+            <a:schemeClr val="lt1"/>
+          </a:fontRef>
+        </p:style>
+        <p:txBody>
+          <a:bodyPr rtlCol="0" anchor="ctr" wrap="square"/>
+          <a:lstStyle/>
+          <a:p>
+            <a:pPr algn="ctr"/>
+            <a:r>
+              <a:rPr sz="1000" b="0">
+                <a:solidFill>
+                  <a:srgbClr val="666666"/>
+                </a:solidFill>
+                <a:latin typeface="微软雅黑"/>
+                <a:ea typeface="微软雅黑"/>
+              </a:rPr>
+              <a:t>PNG
+硬解加速
+（可选）</a:t>
+            </a:r>
+          </a:p>
+        </p:txBody>
+      </p:sp>
+      <p:sp>
+        <p:nvSpPr>
+          <p:cNvPr id="32" name="Rounded Rectangle 31"/>
+          <p:cNvSpPr/>
+          <p:nvPr/>
+        </p:nvSpPr>
+        <p:spPr>
+          <a:xfrm>
+            <a:off x="4800600" y="5989320"/>
+            <a:ext cx="1325880" cy="868680"/>
+          </a:xfrm>
+          <a:prstGeom prst="roundRect">
+            <a:avLst>
+              <a:gd name="adj" fmla="val 8000"/>
+            </a:avLst>
+          </a:prstGeom>
+          <a:solidFill>
+            <a:srgbClr val="EEEEEE"/>
+          </a:solidFill>
+          <a:ln w="12700">
+            <a:solidFill>
+              <a:srgbClr val="666666"/>
+            </a:solidFill>
+          </a:ln>
+        </p:spPr>
+        <p:style>
+          <a:lnRef idx="1">
+            <a:schemeClr val="accent1"/>
+          </a:lnRef>
+          <a:fillRef idx="3">
+            <a:schemeClr val="accent1"/>
+          </a:fillRef>
+          <a:effectRef idx="2">
+            <a:schemeClr val="accent1"/>
+          </a:effectRef>
+          <a:fontRef idx="minor">
+            <a:schemeClr val="lt1"/>
+          </a:fontRef>
+        </p:style>
+        <p:txBody>
+          <a:bodyPr rtlCol="0" anchor="ctr" wrap="square"/>
+          <a:lstStyle/>
+          <a:p>
+            <a:pPr algn="ctr"/>
+            <a:r>
+              <a:rPr sz="1000" b="1">
+                <a:solidFill>
+                  <a:srgbClr val="666666"/>
+                </a:solidFill>
+                <a:latin typeface="微软雅黑"/>
+                <a:ea typeface="微软雅黑"/>
+              </a:rPr>
+              <a:t>GPU
+本沙箱不走</a:t>
+            </a:r>
+          </a:p>
+        </p:txBody>
+      </p:sp>
+      <p:sp>
+        <p:nvSpPr>
+          <p:cNvPr id="33" name="Rounded Rectangle 32"/>
+          <p:cNvSpPr/>
+          <p:nvPr/>
+        </p:nvSpPr>
+        <p:spPr>
+          <a:xfrm>
+            <a:off x="6537960" y="5989320"/>
+            <a:ext cx="1234440" cy="868680"/>
+          </a:xfrm>
+          <a:prstGeom prst="roundRect">
+            <a:avLst>
+              <a:gd name="adj" fmla="val 8000"/>
+            </a:avLst>
+          </a:prstGeom>
+          <a:solidFill>
+            <a:srgbClr val="FFFFFF"/>
+          </a:solidFill>
+          <a:ln w="12700">
+            <a:solidFill>
+              <a:srgbClr val="222222"/>
+            </a:solidFill>
+          </a:ln>
+        </p:spPr>
+        <p:style>
+          <a:lnRef idx="1">
+            <a:schemeClr val="accent1"/>
+          </a:lnRef>
+          <a:fillRef idx="3">
+            <a:schemeClr val="accent1"/>
+          </a:fillRef>
+          <a:effectRef idx="2">
+            <a:schemeClr val="accent1"/>
+          </a:effectRef>
+          <a:fontRef idx="minor">
+            <a:schemeClr val="lt1"/>
+          </a:fontRef>
+        </p:style>
+        <p:txBody>
+          <a:bodyPr rtlCol="0" anchor="ctr" wrap="square"/>
+          <a:lstStyle/>
+          <a:p>
+            <a:pPr algn="ctr"/>
+            <a:r>
+              <a:rPr sz="1000" b="0">
+                <a:solidFill>
+                  <a:srgbClr val="222222"/>
+                </a:solidFill>
+                <a:latin typeface="微软雅黑"/>
+                <a:ea typeface="微软雅黑"/>
+              </a:rPr>
+              <a:t>ION
+内存提供</a:t>
+            </a:r>
+          </a:p>
+        </p:txBody>
+      </p:sp>
+      <p:sp>
+        <p:nvSpPr>
+          <p:cNvPr id="34" name="Rounded Rectangle 33"/>
+          <p:cNvSpPr/>
+          <p:nvPr/>
+        </p:nvSpPr>
+        <p:spPr>
+          <a:xfrm>
+            <a:off x="8001000" y="5989320"/>
+            <a:ext cx="1417320" cy="868680"/>
+          </a:xfrm>
+          <a:prstGeom prst="roundRect">
+            <a:avLst>
+              <a:gd name="adj" fmla="val 8000"/>
+            </a:avLst>
+          </a:prstGeom>
+          <a:solidFill>
+            <a:srgbClr val="EEEEEE"/>
+          </a:solidFill>
+          <a:ln w="12700">
+            <a:solidFill>
+              <a:srgbClr val="666666"/>
+            </a:solidFill>
+          </a:ln>
+        </p:spPr>
+        <p:style>
+          <a:lnRef idx="1">
+            <a:schemeClr val="accent1"/>
+          </a:lnRef>
+          <a:fillRef idx="3">
+            <a:schemeClr val="accent1"/>
+          </a:fillRef>
+          <a:effectRef idx="2">
+            <a:schemeClr val="accent1"/>
+          </a:effectRef>
+          <a:fontRef idx="minor">
+            <a:schemeClr val="lt1"/>
+          </a:fontRef>
+        </p:style>
+        <p:txBody>
+          <a:bodyPr rtlCol="0" anchor="ctr" wrap="square"/>
+          <a:lstStyle/>
+          <a:p>
+            <a:pPr algn="ctr"/>
+            <a:r>
+              <a:rPr sz="1000" b="0">
+                <a:solidFill>
+                  <a:srgbClr val="666666"/>
+                </a:solidFill>
+                <a:latin typeface="微软雅黑"/>
+                <a:ea typeface="微软雅黑"/>
+              </a:rPr>
+              <a:t>叠加加速器
+（可选）</a:t>
+            </a:r>
+          </a:p>
+        </p:txBody>
+      </p:sp>
+      <p:sp>
+        <p:nvSpPr>
+          <p:cNvPr id="35" name="Rounded Rectangle 34"/>
+          <p:cNvSpPr/>
+          <p:nvPr/>
+        </p:nvSpPr>
+        <p:spPr>
+          <a:xfrm>
+            <a:off x="9601200" y="5989320"/>
+            <a:ext cx="1325880" cy="868680"/>
+          </a:xfrm>
+          <a:prstGeom prst="roundRect">
+            <a:avLst>
+              <a:gd name="adj" fmla="val 8000"/>
+            </a:avLst>
+          </a:prstGeom>
+          <a:solidFill>
+            <a:srgbClr val="FFFFFF"/>
+          </a:solidFill>
+          <a:ln w="12700">
+            <a:solidFill>
+              <a:srgbClr val="222222"/>
+            </a:solidFill>
+          </a:ln>
+        </p:spPr>
+        <p:style>
+          <a:lnRef idx="1">
+            <a:schemeClr val="accent1"/>
+          </a:lnRef>
+          <a:fillRef idx="3">
+            <a:schemeClr val="accent1"/>
+          </a:fillRef>
+          <a:effectRef idx="2">
+            <a:schemeClr val="accent1"/>
+          </a:effectRef>
+          <a:fontRef idx="minor">
+            <a:schemeClr val="lt1"/>
+          </a:fontRef>
+        </p:style>
+        <p:txBody>
+          <a:bodyPr rtlCol="0" anchor="ctr" wrap="square"/>
+          <a:lstStyle/>
+          <a:p>
+            <a:pPr algn="ctr"/>
+            <a:r>
+              <a:rPr sz="1000" b="0">
+                <a:solidFill>
+                  <a:srgbClr val="222222"/>
+                </a:solidFill>
+                <a:latin typeface="微软雅黑"/>
+                <a:ea typeface="微软雅黑"/>
+              </a:rPr>
+              <a:t>FB
+图形图层</a:t>
+            </a:r>
+          </a:p>
+        </p:txBody>
+      </p:sp>
+      <p:sp>
+        <p:nvSpPr>
+          <p:cNvPr id="36" name="Rounded Rectangle 35"/>
+          <p:cNvSpPr/>
+          <p:nvPr/>
+        </p:nvSpPr>
+        <p:spPr>
+          <a:xfrm>
+            <a:off x="11109960" y="5989320"/>
+            <a:ext cx="1417320" cy="868680"/>
+          </a:xfrm>
+          <a:prstGeom prst="roundRect">
+            <a:avLst>
+              <a:gd name="adj" fmla="val 8000"/>
+            </a:avLst>
+          </a:prstGeom>
+          <a:solidFill>
+            <a:srgbClr val="EEEEEE"/>
+          </a:solidFill>
+          <a:ln w="12700">
+            <a:solidFill>
+              <a:srgbClr val="666666"/>
+            </a:solidFill>
+          </a:ln>
+        </p:spPr>
+        <p:style>
+          <a:lnRef idx="1">
+            <a:schemeClr val="accent1"/>
+          </a:lnRef>
+          <a:fillRef idx="3">
+            <a:schemeClr val="accent1"/>
+          </a:fillRef>
+          <a:effectRef idx="2">
+            <a:schemeClr val="accent1"/>
+          </a:effectRef>
+          <a:fontRef idx="minor">
+            <a:schemeClr val="lt1"/>
+          </a:fontRef>
+        </p:style>
+        <p:txBody>
+          <a:bodyPr rtlCol="0" anchor="ctr" wrap="square"/>
+          <a:lstStyle/>
+          <a:p>
+            <a:pPr algn="ctr"/>
+            <a:r>
+              <a:rPr sz="1000" b="0">
+                <a:solidFill>
+                  <a:srgbClr val="666666"/>
+                </a:solidFill>
+                <a:latin typeface="微软雅黑"/>
+                <a:ea typeface="微软雅黑"/>
+              </a:rPr>
+              <a:t>视频通路
+（可选）</a:t>
+            </a:r>
+          </a:p>
+        </p:txBody>
+      </p:sp>
+      <p:sp>
+        <p:nvSpPr>
+          <p:cNvPr id="37" name="TextBox 36"/>
+          <p:cNvSpPr txBox="1"/>
+          <p:nvPr/>
+        </p:nvSpPr>
+        <p:spPr>
+          <a:xfrm>
+            <a:off x="1691640" y="7589520"/>
+            <a:ext cx="2926080" cy="256032"/>
+          </a:xfrm>
+          <a:prstGeom prst="rect">
+            <a:avLst/>
+          </a:prstGeom>
+          <a:noFill/>
+        </p:spPr>
+        <p:txBody>
+          <a:bodyPr wrap="square" anchor="ctr"/>
+          <a:lstStyle/>
+          <a:p>
+            <a:pPr algn="ctr"/>
+            <a:r>
+              <a:rPr sz="900" b="0">
+                <a:solidFill>
+                  <a:srgbClr val="666666"/>
+                </a:solidFill>
+                <a:latin typeface="微软雅黑"/>
+                <a:ea typeface="微软雅黑"/>
+              </a:rPr>
+              <a:t>图形加速解码器类</a:t>
+            </a:r>
+          </a:p>
+        </p:txBody>
+      </p:sp>
+      <p:sp>
+        <p:nvSpPr>
+          <p:cNvPr id="38" name="TextBox 37"/>
+          <p:cNvSpPr txBox="1"/>
+          <p:nvPr/>
+        </p:nvSpPr>
+        <p:spPr>
+          <a:xfrm>
+            <a:off x="4800600" y="7589520"/>
+            <a:ext cx="1325880" cy="256032"/>
+          </a:xfrm>
+          <a:prstGeom prst="rect">
+            <a:avLst/>
+          </a:prstGeom>
+          <a:noFill/>
+        </p:spPr>
+        <p:txBody>
+          <a:bodyPr wrap="square" anchor="ctr"/>
+          <a:lstStyle/>
+          <a:p>
+            <a:pPr algn="ctr"/>
+            <a:r>
+              <a:rPr sz="900" b="0">
+                <a:solidFill>
+                  <a:srgbClr val="666666"/>
+                </a:solidFill>
+                <a:latin typeface="微软雅黑"/>
+                <a:ea typeface="微软雅黑"/>
+              </a:rPr>
+              <a:t>图形通用绘制</a:t>
+            </a:r>
+          </a:p>
+        </p:txBody>
+      </p:sp>
+      <p:sp>
+        <p:nvSpPr>
+          <p:cNvPr id="39" name="TextBox 38"/>
+          <p:cNvSpPr txBox="1"/>
+          <p:nvPr/>
+        </p:nvSpPr>
+        <p:spPr>
+          <a:xfrm>
+            <a:off x="6537960" y="7589520"/>
+            <a:ext cx="1234440" cy="256032"/>
+          </a:xfrm>
+          <a:prstGeom prst="rect">
+            <a:avLst/>
+          </a:prstGeom>
+          <a:noFill/>
+        </p:spPr>
+        <p:txBody>
+          <a:bodyPr wrap="square" anchor="ctr"/>
+          <a:lstStyle/>
+          <a:p>
+            <a:pPr algn="ctr"/>
+            <a:r>
+              <a:rPr sz="900" b="0">
+                <a:solidFill>
+                  <a:srgbClr val="666666"/>
+                </a:solidFill>
+                <a:latin typeface="微软雅黑"/>
+                <a:ea typeface="微软雅黑"/>
+              </a:rPr>
+              <a:t>内存提供</a:t>
+            </a:r>
+          </a:p>
+        </p:txBody>
+      </p:sp>
+      <p:sp>
+        <p:nvSpPr>
+          <p:cNvPr id="40" name="TextBox 39"/>
+          <p:cNvSpPr txBox="1"/>
+          <p:nvPr/>
+        </p:nvSpPr>
+        <p:spPr>
+          <a:xfrm>
+            <a:off x="8001000" y="7589520"/>
+            <a:ext cx="1417320" cy="256032"/>
+          </a:xfrm>
+          <a:prstGeom prst="rect">
+            <a:avLst/>
+          </a:prstGeom>
+          <a:noFill/>
+        </p:spPr>
+        <p:txBody>
+          <a:bodyPr wrap="square" anchor="ctr"/>
+          <a:lstStyle/>
+          <a:p>
+            <a:pPr algn="ctr"/>
+            <a:r>
+              <a:rPr sz="900" b="0">
+                <a:solidFill>
+                  <a:srgbClr val="666666"/>
+                </a:solidFill>
+                <a:latin typeface="微软雅黑"/>
+                <a:ea typeface="微软雅黑"/>
+              </a:rPr>
+              <a:t>叠加加速</a:t>
+            </a:r>
+          </a:p>
+        </p:txBody>
+      </p:sp>
+      <p:sp>
+        <p:nvSpPr>
+          <p:cNvPr id="41" name="TextBox 40"/>
+          <p:cNvSpPr txBox="1"/>
+          <p:nvPr/>
+        </p:nvSpPr>
+        <p:spPr>
+          <a:xfrm>
+            <a:off x="9601200" y="7589520"/>
+            <a:ext cx="2926080" cy="256032"/>
+          </a:xfrm>
+          <a:prstGeom prst="rect">
+            <a:avLst/>
+          </a:prstGeom>
+          <a:noFill/>
+        </p:spPr>
+        <p:txBody>
+          <a:bodyPr wrap="square" anchor="ctr"/>
+          <a:lstStyle/>
+          <a:p>
+            <a:pPr algn="ctr"/>
+            <a:r>
+              <a:rPr sz="900" b="0">
+                <a:solidFill>
+                  <a:srgbClr val="666666"/>
+                </a:solidFill>
+                <a:latin typeface="微软雅黑"/>
+                <a:ea typeface="微软雅黑"/>
+              </a:rPr>
+              <a:t>显示层</a:t>
+            </a:r>
+          </a:p>
+        </p:txBody>
+      </p:sp>
+      <p:cxnSp>
+        <p:nvCxnSpPr>
+          <p:cNvPr id="42" name="Connector 41"/>
+          <p:cNvCxnSpPr/>
+          <p:nvPr/>
+        </p:nvCxnSpPr>
+        <p:spPr>
+          <a:xfrm>
+            <a:off x="2537460" y="1280160"/>
+            <a:ext cx="0" cy="502920"/>
+          </a:xfrm>
+          <a:prstGeom prst="line">
+            <a:avLst/>
+          </a:prstGeom>
+          <a:ln w="22225">
+            <a:solidFill>
+              <a:srgbClr val="D03232"/>
+            </a:solidFill>
+            <a:tailEnd type="triangle" w="med" len="med"/>
+          </a:ln>
+        </p:spPr>
+        <p:style>
+          <a:lnRef idx="2">
+            <a:schemeClr val="accent1"/>
+          </a:lnRef>
+          <a:fillRef idx="0">
+            <a:schemeClr val="accent1"/>
+          </a:fillRef>
+          <a:effectRef idx="1">
+            <a:schemeClr val="accent1"/>
+          </a:effectRef>
+          <a:fontRef idx="minor">
+            <a:schemeClr val="tx1"/>
+          </a:fontRef>
+        </p:style>
+      </p:cxnSp>
+      <p:cxnSp>
+        <p:nvCxnSpPr>
+          <p:cNvPr id="43" name="Connector 42"/>
+          <p:cNvCxnSpPr/>
+          <p:nvPr/>
+        </p:nvCxnSpPr>
+        <p:spPr>
+          <a:xfrm>
+            <a:off x="4869180" y="1225295"/>
+            <a:ext cx="0" cy="557785"/>
+          </a:xfrm>
+          <a:prstGeom prst="line">
+            <a:avLst/>
+          </a:prstGeom>
+          <a:ln w="22225">
+            <a:solidFill>
+              <a:srgbClr val="D03232"/>
+            </a:solidFill>
+            <a:tailEnd type="triangle" w="med" len="med"/>
+          </a:ln>
+        </p:spPr>
+        <p:style>
+          <a:lnRef idx="2">
+            <a:schemeClr val="accent1"/>
+          </a:lnRef>
+          <a:fillRef idx="0">
+            <a:schemeClr val="accent1"/>
+          </a:fillRef>
+          <a:effectRef idx="1">
+            <a:schemeClr val="accent1"/>
+          </a:effectRef>
+          <a:fontRef idx="minor">
+            <a:schemeClr val="tx1"/>
+          </a:fontRef>
+        </p:style>
+      </p:cxnSp>
+      <p:cxnSp>
+        <p:nvCxnSpPr>
+          <p:cNvPr id="44" name="Connector 43"/>
+          <p:cNvCxnSpPr/>
+          <p:nvPr/>
+        </p:nvCxnSpPr>
+        <p:spPr>
+          <a:xfrm flipH="1">
+            <a:off x="3223260" y="2167128"/>
+            <a:ext cx="365759" cy="164592"/>
+          </a:xfrm>
+          <a:prstGeom prst="line">
+            <a:avLst/>
+          </a:prstGeom>
+          <a:ln w="22225">
+            <a:solidFill>
+              <a:srgbClr val="D03232"/>
+            </a:solidFill>
+            <a:tailEnd type="triangle" w="med" len="med"/>
+          </a:ln>
+        </p:spPr>
+        <p:style>
+          <a:lnRef idx="2">
+            <a:schemeClr val="accent1"/>
+          </a:lnRef>
+          <a:fillRef idx="0">
+            <a:schemeClr val="accent1"/>
+          </a:fillRef>
+          <a:effectRef idx="1">
+            <a:schemeClr val="accent1"/>
+          </a:effectRef>
+          <a:fontRef idx="minor">
+            <a:schemeClr val="tx1"/>
+          </a:fontRef>
+        </p:style>
+      </p:cxnSp>
+      <p:cxnSp>
+        <p:nvCxnSpPr>
+          <p:cNvPr id="45" name="Connector 44"/>
+          <p:cNvCxnSpPr/>
+          <p:nvPr/>
+        </p:nvCxnSpPr>
+        <p:spPr>
+          <a:xfrm flipH="1">
+            <a:off x="4594860" y="2167128"/>
+            <a:ext cx="457199" cy="164592"/>
+          </a:xfrm>
+          <a:prstGeom prst="line">
+            <a:avLst/>
+          </a:prstGeom>
+          <a:ln w="22225">
+            <a:solidFill>
+              <a:srgbClr val="D03232"/>
+            </a:solidFill>
+            <a:tailEnd type="triangle" w="med" len="med"/>
+          </a:ln>
+        </p:spPr>
+        <p:style>
+          <a:lnRef idx="2">
+            <a:schemeClr val="accent1"/>
+          </a:lnRef>
+          <a:fillRef idx="0">
+            <a:schemeClr val="accent1"/>
+          </a:fillRef>
+          <a:effectRef idx="1">
+            <a:schemeClr val="accent1"/>
+          </a:effectRef>
+          <a:fontRef idx="minor">
+            <a:schemeClr val="tx1"/>
+          </a:fontRef>
+        </p:style>
+      </p:cxnSp>
+      <p:cxnSp>
+        <p:nvCxnSpPr>
+          <p:cNvPr id="46" name="Connector 45"/>
+          <p:cNvCxnSpPr/>
+          <p:nvPr/>
+        </p:nvCxnSpPr>
+        <p:spPr>
+          <a:xfrm flipH="1">
+            <a:off x="5920740" y="2167128"/>
+            <a:ext cx="411479" cy="164592"/>
+          </a:xfrm>
+          <a:prstGeom prst="line">
+            <a:avLst/>
+          </a:prstGeom>
+          <a:ln w="22225">
+            <a:solidFill>
+              <a:srgbClr val="D03232"/>
+            </a:solidFill>
+            <a:tailEnd type="triangle" w="med" len="med"/>
+          </a:ln>
+        </p:spPr>
+        <p:style>
+          <a:lnRef idx="2">
+            <a:schemeClr val="accent1"/>
+          </a:lnRef>
+          <a:fillRef idx="0">
+            <a:schemeClr val="accent1"/>
+          </a:fillRef>
+          <a:effectRef idx="1">
+            <a:schemeClr val="accent1"/>
+          </a:effectRef>
+          <a:fontRef idx="minor">
+            <a:schemeClr val="tx1"/>
+          </a:fontRef>
+        </p:style>
+      </p:cxnSp>
+      <p:cxnSp>
+        <p:nvCxnSpPr>
+          <p:cNvPr id="47" name="Connector 46"/>
+          <p:cNvCxnSpPr/>
+          <p:nvPr/>
+        </p:nvCxnSpPr>
+        <p:spPr>
+          <a:xfrm>
+            <a:off x="2606040" y="2551176"/>
+            <a:ext cx="228600" cy="612648"/>
+          </a:xfrm>
+          <a:prstGeom prst="line">
+            <a:avLst/>
+          </a:prstGeom>
+          <a:ln w="22225">
+            <a:solidFill>
+              <a:srgbClr val="D03232"/>
+            </a:solidFill>
+            <a:tailEnd type="triangle" w="med" len="med"/>
+          </a:ln>
+        </p:spPr>
+        <p:style>
+          <a:lnRef idx="2">
+            <a:schemeClr val="accent1"/>
+          </a:lnRef>
+          <a:fillRef idx="0">
+            <a:schemeClr val="accent1"/>
+          </a:fillRef>
+          <a:effectRef idx="1">
+            <a:schemeClr val="accent1"/>
+          </a:effectRef>
+          <a:fontRef idx="minor">
+            <a:schemeClr val="tx1"/>
+          </a:fontRef>
+        </p:style>
+      </p:cxnSp>
+      <p:cxnSp>
+        <p:nvCxnSpPr>
+          <p:cNvPr id="48" name="Connector 47"/>
+          <p:cNvCxnSpPr/>
+          <p:nvPr/>
+        </p:nvCxnSpPr>
+        <p:spPr>
+          <a:xfrm>
+            <a:off x="3223260" y="2770632"/>
+            <a:ext cx="1005840" cy="630936"/>
+          </a:xfrm>
+          <a:prstGeom prst="line">
+            <a:avLst/>
+          </a:prstGeom>
+          <a:ln w="22225">
+            <a:solidFill>
+              <a:srgbClr val="D03232"/>
+            </a:solidFill>
+            <a:tailEnd type="triangle" w="med" len="med"/>
+          </a:ln>
+        </p:spPr>
+        <p:style>
+          <a:lnRef idx="2">
+            <a:schemeClr val="accent1"/>
+          </a:lnRef>
+          <a:fillRef idx="0">
+            <a:schemeClr val="accent1"/>
+          </a:fillRef>
+          <a:effectRef idx="1">
+            <a:schemeClr val="accent1"/>
+          </a:effectRef>
+          <a:fontRef idx="minor">
+            <a:schemeClr val="tx1"/>
+          </a:fontRef>
+        </p:style>
+      </p:cxnSp>
+      <p:cxnSp>
+        <p:nvCxnSpPr>
+          <p:cNvPr id="49" name="Connector 48"/>
+          <p:cNvCxnSpPr/>
+          <p:nvPr/>
+        </p:nvCxnSpPr>
+        <p:spPr>
+          <a:xfrm flipH="1">
+            <a:off x="4549140" y="2770632"/>
+            <a:ext cx="45720" cy="630936"/>
+          </a:xfrm>
+          <a:prstGeom prst="line">
+            <a:avLst/>
+          </a:prstGeom>
+          <a:ln w="22225">
+            <a:solidFill>
+              <a:srgbClr val="D03232"/>
+            </a:solidFill>
+            <a:tailEnd type="triangle" w="med" len="med"/>
+          </a:ln>
+        </p:spPr>
+        <p:style>
+          <a:lnRef idx="2">
+            <a:schemeClr val="accent1"/>
+          </a:lnRef>
+          <a:fillRef idx="0">
+            <a:schemeClr val="accent1"/>
+          </a:fillRef>
+          <a:effectRef idx="1">
+            <a:schemeClr val="accent1"/>
+          </a:effectRef>
+          <a:fontRef idx="minor">
+            <a:schemeClr val="tx1"/>
+          </a:fontRef>
+        </p:style>
+      </p:cxnSp>
+      <p:cxnSp>
+        <p:nvCxnSpPr>
+          <p:cNvPr id="50" name="Connector 49"/>
+          <p:cNvCxnSpPr/>
+          <p:nvPr/>
+        </p:nvCxnSpPr>
+        <p:spPr>
+          <a:xfrm>
+            <a:off x="4229100" y="3858768"/>
+            <a:ext cx="22860" cy="237744"/>
+          </a:xfrm>
+          <a:prstGeom prst="line">
+            <a:avLst/>
+          </a:prstGeom>
+          <a:ln w="28575">
+            <a:solidFill>
+              <a:srgbClr val="C96C16"/>
+            </a:solidFill>
+            <a:tailEnd type="triangle" w="med" len="med"/>
+          </a:ln>
+        </p:spPr>
+        <p:style>
+          <a:lnRef idx="2">
+            <a:schemeClr val="accent1"/>
+          </a:lnRef>
+          <a:fillRef idx="0">
+            <a:schemeClr val="accent1"/>
+          </a:fillRef>
+          <a:effectRef idx="1">
+            <a:schemeClr val="accent1"/>
+          </a:effectRef>
+          <a:fontRef idx="minor">
+            <a:schemeClr val="tx1"/>
+          </a:fontRef>
+        </p:style>
+      </p:cxnSp>
+      <p:cxnSp>
+        <p:nvCxnSpPr>
+          <p:cNvPr id="51" name="Connector 50"/>
+          <p:cNvCxnSpPr/>
+          <p:nvPr/>
+        </p:nvCxnSpPr>
+        <p:spPr>
+          <a:xfrm>
+            <a:off x="5920740" y="2770632"/>
+            <a:ext cx="0" cy="1591056"/>
+          </a:xfrm>
+          <a:prstGeom prst="line">
+            <a:avLst/>
+          </a:prstGeom>
+          <a:ln w="25400">
+            <a:solidFill>
+              <a:srgbClr val="C96C16"/>
+            </a:solidFill>
+          </a:ln>
+        </p:spPr>
+        <p:style>
+          <a:lnRef idx="2">
+            <a:schemeClr val="accent1"/>
+          </a:lnRef>
+          <a:fillRef idx="0">
+            <a:schemeClr val="accent1"/>
+          </a:fillRef>
+          <a:effectRef idx="1">
+            <a:schemeClr val="accent1"/>
+          </a:effectRef>
+          <a:fontRef idx="minor">
+            <a:schemeClr val="tx1"/>
+          </a:fontRef>
+        </p:style>
+      </p:cxnSp>
+      <p:cxnSp>
+        <p:nvCxnSpPr>
+          <p:cNvPr id="52" name="Connector 51"/>
+          <p:cNvCxnSpPr/>
+          <p:nvPr/>
+        </p:nvCxnSpPr>
+        <p:spPr>
+          <a:xfrm flipH="1">
+            <a:off x="5394960" y="4361688"/>
+            <a:ext cx="525780" cy="0"/>
+          </a:xfrm>
+          <a:prstGeom prst="line">
+            <a:avLst/>
+          </a:prstGeom>
+          <a:ln w="25400">
+            <a:solidFill>
+              <a:srgbClr val="C96C16"/>
+            </a:solidFill>
+            <a:tailEnd type="triangle" w="med" len="med"/>
+          </a:ln>
+        </p:spPr>
+        <p:style>
+          <a:lnRef idx="2">
+            <a:schemeClr val="accent1"/>
+          </a:lnRef>
+          <a:fillRef idx="0">
+            <a:schemeClr val="accent1"/>
+          </a:fillRef>
+          <a:effectRef idx="1">
+            <a:schemeClr val="accent1"/>
+          </a:effectRef>
+          <a:fontRef idx="minor">
+            <a:schemeClr val="tx1"/>
+          </a:fontRef>
+        </p:style>
+      </p:cxnSp>
+      <p:cxnSp>
+        <p:nvCxnSpPr>
+          <p:cNvPr id="53" name="Connector 52"/>
+          <p:cNvCxnSpPr/>
+          <p:nvPr/>
+        </p:nvCxnSpPr>
+        <p:spPr>
+          <a:xfrm>
+            <a:off x="4251960" y="4626864"/>
+            <a:ext cx="0" cy="182880"/>
+          </a:xfrm>
+          <a:prstGeom prst="line">
+            <a:avLst/>
+          </a:prstGeom>
+          <a:ln w="25400">
+            <a:solidFill>
+              <a:srgbClr val="C96C16"/>
+            </a:solidFill>
+          </a:ln>
+        </p:spPr>
+        <p:style>
+          <a:lnRef idx="2">
+            <a:schemeClr val="accent1"/>
+          </a:lnRef>
+          <a:fillRef idx="0">
+            <a:schemeClr val="accent1"/>
+          </a:fillRef>
+          <a:effectRef idx="1">
+            <a:schemeClr val="accent1"/>
+          </a:effectRef>
+          <a:fontRef idx="minor">
+            <a:schemeClr val="tx1"/>
+          </a:fontRef>
+        </p:style>
+      </p:cxnSp>
+      <p:cxnSp>
+        <p:nvCxnSpPr>
+          <p:cNvPr id="54" name="Connector 53"/>
+          <p:cNvCxnSpPr/>
+          <p:nvPr/>
+        </p:nvCxnSpPr>
+        <p:spPr>
+          <a:xfrm>
+            <a:off x="4251960" y="4809744"/>
+            <a:ext cx="2834640" cy="0"/>
+          </a:xfrm>
+          <a:prstGeom prst="line">
+            <a:avLst/>
+          </a:prstGeom>
+          <a:ln w="25400">
+            <a:solidFill>
+              <a:srgbClr val="C96C16"/>
+            </a:solidFill>
+          </a:ln>
+        </p:spPr>
+        <p:style>
+          <a:lnRef idx="2">
+            <a:schemeClr val="accent1"/>
+          </a:lnRef>
+          <a:fillRef idx="0">
+            <a:schemeClr val="accent1"/>
+          </a:fillRef>
+          <a:effectRef idx="1">
+            <a:schemeClr val="accent1"/>
+          </a:effectRef>
+          <a:fontRef idx="minor">
+            <a:schemeClr val="tx1"/>
+          </a:fontRef>
+        </p:style>
+      </p:cxnSp>
+      <p:cxnSp>
+        <p:nvCxnSpPr>
+          <p:cNvPr id="55" name="Connector 54"/>
+          <p:cNvCxnSpPr/>
+          <p:nvPr/>
+        </p:nvCxnSpPr>
+        <p:spPr>
+          <a:xfrm>
+            <a:off x="7086600" y="4809744"/>
+            <a:ext cx="0" cy="109728"/>
+          </a:xfrm>
+          <a:prstGeom prst="line">
+            <a:avLst/>
+          </a:prstGeom>
+          <a:ln w="25400">
+            <a:solidFill>
+              <a:srgbClr val="C96C16"/>
+            </a:solidFill>
+            <a:tailEnd type="triangle" w="med" len="med"/>
+          </a:ln>
+        </p:spPr>
+        <p:style>
+          <a:lnRef idx="2">
+            <a:schemeClr val="accent1"/>
+          </a:lnRef>
+          <a:fillRef idx="0">
+            <a:schemeClr val="accent1"/>
+          </a:fillRef>
+          <a:effectRef idx="1">
+            <a:schemeClr val="accent1"/>
+          </a:effectRef>
+          <a:fontRef idx="minor">
+            <a:schemeClr val="tx1"/>
+          </a:fontRef>
+        </p:style>
+      </p:cxnSp>
+      <p:cxnSp>
+        <p:nvCxnSpPr>
+          <p:cNvPr id="56" name="Connector 55"/>
+          <p:cNvCxnSpPr/>
+          <p:nvPr/>
+        </p:nvCxnSpPr>
+        <p:spPr>
+          <a:xfrm>
+            <a:off x="3429000" y="3858768"/>
+            <a:ext cx="2034540" cy="2130552"/>
+          </a:xfrm>
+          <a:prstGeom prst="line">
+            <a:avLst/>
+          </a:prstGeom>
+          <a:ln w="15875">
+            <a:solidFill>
+              <a:srgbClr val="666666"/>
+            </a:solidFill>
+            <a:tailEnd type="triangle" w="med" len="med"/>
+            <a:prstDash val="dash"/>
+          </a:ln>
+        </p:spPr>
+        <p:style>
+          <a:lnRef idx="2">
+            <a:schemeClr val="accent1"/>
+          </a:lnRef>
+          <a:fillRef idx="0">
+            <a:schemeClr val="accent1"/>
+          </a:fillRef>
+          <a:effectRef idx="1">
+            <a:schemeClr val="accent1"/>
+          </a:effectRef>
+          <a:fontRef idx="minor">
+            <a:schemeClr val="tx1"/>
+          </a:fontRef>
+        </p:style>
+      </p:cxnSp>
+      <p:cxnSp>
+        <p:nvCxnSpPr>
+          <p:cNvPr id="57" name="Connector 56"/>
+          <p:cNvCxnSpPr/>
+          <p:nvPr/>
+        </p:nvCxnSpPr>
+        <p:spPr>
+          <a:xfrm>
+            <a:off x="8709660" y="1225295"/>
+            <a:ext cx="0" cy="557785"/>
+          </a:xfrm>
+          <a:prstGeom prst="line">
+            <a:avLst/>
+          </a:prstGeom>
+          <a:ln w="17780">
+            <a:solidFill>
+              <a:srgbClr val="222222"/>
+            </a:solidFill>
+            <a:tailEnd type="triangle" w="med" len="med"/>
+          </a:ln>
+        </p:spPr>
+        <p:style>
+          <a:lnRef idx="2">
+            <a:schemeClr val="accent1"/>
+          </a:lnRef>
+          <a:fillRef idx="0">
+            <a:schemeClr val="accent1"/>
+          </a:fillRef>
+          <a:effectRef idx="1">
+            <a:schemeClr val="accent1"/>
+          </a:effectRef>
+          <a:fontRef idx="minor">
+            <a:schemeClr val="tx1"/>
+          </a:fontRef>
+        </p:style>
+      </p:cxnSp>
+      <p:cxnSp>
+        <p:nvCxnSpPr>
+          <p:cNvPr id="58" name="Connector 57"/>
+          <p:cNvCxnSpPr/>
+          <p:nvPr/>
+        </p:nvCxnSpPr>
+        <p:spPr>
+          <a:xfrm flipH="1">
+            <a:off x="7978140" y="2167128"/>
+            <a:ext cx="160020" cy="164592"/>
+          </a:xfrm>
+          <a:prstGeom prst="line">
+            <a:avLst/>
+          </a:prstGeom>
+          <a:ln w="17780">
+            <a:solidFill>
+              <a:srgbClr val="222222"/>
+            </a:solidFill>
+            <a:tailEnd type="triangle" w="med" len="med"/>
+          </a:ln>
+        </p:spPr>
+        <p:style>
+          <a:lnRef idx="2">
+            <a:schemeClr val="accent1"/>
+          </a:lnRef>
+          <a:fillRef idx="0">
+            <a:schemeClr val="accent1"/>
+          </a:fillRef>
+          <a:effectRef idx="1">
+            <a:schemeClr val="accent1"/>
+          </a:effectRef>
+          <a:fontRef idx="minor">
+            <a:schemeClr val="tx1"/>
+          </a:fontRef>
+        </p:style>
+      </p:cxnSp>
+      <p:cxnSp>
+        <p:nvCxnSpPr>
+          <p:cNvPr id="59" name="Connector 58"/>
+          <p:cNvCxnSpPr/>
+          <p:nvPr/>
+        </p:nvCxnSpPr>
+        <p:spPr>
+          <a:xfrm flipV="1">
+            <a:off x="8641080" y="2496312"/>
+            <a:ext cx="2651760" cy="54864"/>
+          </a:xfrm>
+          <a:prstGeom prst="line">
+            <a:avLst/>
+          </a:prstGeom>
+          <a:ln w="17780">
+            <a:solidFill>
+              <a:srgbClr val="222222"/>
+            </a:solidFill>
+            <a:tailEnd type="triangle" w="med" len="med"/>
+          </a:ln>
+        </p:spPr>
+        <p:style>
+          <a:lnRef idx="2">
+            <a:schemeClr val="accent1"/>
+          </a:lnRef>
+          <a:fillRef idx="0">
+            <a:schemeClr val="accent1"/>
+          </a:fillRef>
+          <a:effectRef idx="1">
+            <a:schemeClr val="accent1"/>
+          </a:effectRef>
+          <a:fontRef idx="minor">
+            <a:schemeClr val="tx1"/>
+          </a:fontRef>
+        </p:style>
+      </p:cxnSp>
+      <p:cxnSp>
+        <p:nvCxnSpPr>
+          <p:cNvPr id="60" name="Connector 59"/>
+          <p:cNvCxnSpPr/>
+          <p:nvPr/>
+        </p:nvCxnSpPr>
+        <p:spPr>
+          <a:xfrm>
+            <a:off x="7978140" y="2770632"/>
+            <a:ext cx="548640" cy="137160"/>
+          </a:xfrm>
+          <a:prstGeom prst="line">
+            <a:avLst/>
+          </a:prstGeom>
+          <a:ln w="17780">
+            <a:solidFill>
+              <a:srgbClr val="222222"/>
+            </a:solidFill>
+            <a:tailEnd type="triangle" w="med" len="med"/>
+          </a:ln>
+        </p:spPr>
+        <p:style>
+          <a:lnRef idx="2">
+            <a:schemeClr val="accent1"/>
+          </a:lnRef>
+          <a:fillRef idx="0">
+            <a:schemeClr val="accent1"/>
+          </a:fillRef>
+          <a:effectRef idx="1">
+            <a:schemeClr val="accent1"/>
+          </a:effectRef>
+          <a:fontRef idx="minor">
+            <a:schemeClr val="tx1"/>
+          </a:fontRef>
+        </p:style>
+      </p:cxnSp>
+      <p:cxnSp>
+        <p:nvCxnSpPr>
+          <p:cNvPr id="61" name="Connector 60"/>
+          <p:cNvCxnSpPr/>
+          <p:nvPr/>
+        </p:nvCxnSpPr>
+        <p:spPr>
+          <a:xfrm flipH="1">
+            <a:off x="7795260" y="3383280"/>
+            <a:ext cx="365760" cy="320040"/>
+          </a:xfrm>
+          <a:prstGeom prst="line">
+            <a:avLst/>
+          </a:prstGeom>
+          <a:ln w="17780">
+            <a:solidFill>
+              <a:srgbClr val="222222"/>
+            </a:solidFill>
+            <a:tailEnd type="triangle" w="med" len="med"/>
+          </a:ln>
+        </p:spPr>
+        <p:style>
+          <a:lnRef idx="2">
+            <a:schemeClr val="accent1"/>
+          </a:lnRef>
+          <a:fillRef idx="0">
+            <a:schemeClr val="accent1"/>
+          </a:fillRef>
+          <a:effectRef idx="1">
+            <a:schemeClr val="accent1"/>
+          </a:effectRef>
+          <a:fontRef idx="minor">
+            <a:schemeClr val="tx1"/>
+          </a:fontRef>
+        </p:style>
+      </p:cxnSp>
+      <p:cxnSp>
+        <p:nvCxnSpPr>
+          <p:cNvPr id="62" name="Connector 61"/>
+          <p:cNvCxnSpPr/>
+          <p:nvPr/>
+        </p:nvCxnSpPr>
+        <p:spPr>
+          <a:xfrm>
+            <a:off x="8983980" y="3383280"/>
+            <a:ext cx="1005839" cy="320040"/>
+          </a:xfrm>
+          <a:prstGeom prst="line">
+            <a:avLst/>
+          </a:prstGeom>
+          <a:ln w="17780">
+            <a:solidFill>
+              <a:srgbClr val="222222"/>
+            </a:solidFill>
+            <a:tailEnd type="triangle" w="med" len="med"/>
+          </a:ln>
+        </p:spPr>
+        <p:style>
+          <a:lnRef idx="2">
+            <a:schemeClr val="accent1"/>
+          </a:lnRef>
+          <a:fillRef idx="0">
+            <a:schemeClr val="accent1"/>
+          </a:fillRef>
+          <a:effectRef idx="1">
+            <a:schemeClr val="accent1"/>
+          </a:effectRef>
+          <a:fontRef idx="minor">
+            <a:schemeClr val="tx1"/>
+          </a:fontRef>
+        </p:style>
+      </p:cxnSp>
+      <p:cxnSp>
+        <p:nvCxnSpPr>
+          <p:cNvPr id="63" name="Connector 62"/>
+          <p:cNvCxnSpPr/>
+          <p:nvPr/>
+        </p:nvCxnSpPr>
+        <p:spPr>
+          <a:xfrm>
+            <a:off x="7795260" y="4206240"/>
+            <a:ext cx="0" cy="713232"/>
+          </a:xfrm>
+          <a:prstGeom prst="line">
+            <a:avLst/>
+          </a:prstGeom>
+          <a:ln w="17780">
+            <a:solidFill>
+              <a:srgbClr val="222222"/>
+            </a:solidFill>
+            <a:tailEnd type="triangle" w="med" len="med"/>
+          </a:ln>
+        </p:spPr>
+        <p:style>
+          <a:lnRef idx="2">
+            <a:schemeClr val="accent1"/>
+          </a:lnRef>
+          <a:fillRef idx="0">
+            <a:schemeClr val="accent1"/>
+          </a:fillRef>
+          <a:effectRef idx="1">
+            <a:schemeClr val="accent1"/>
+          </a:effectRef>
+          <a:fontRef idx="minor">
+            <a:schemeClr val="tx1"/>
+          </a:fontRef>
+        </p:style>
+      </p:cxnSp>
+      <p:cxnSp>
+        <p:nvCxnSpPr>
+          <p:cNvPr id="64" name="Connector 63"/>
+          <p:cNvCxnSpPr/>
+          <p:nvPr/>
+        </p:nvCxnSpPr>
+        <p:spPr>
+          <a:xfrm flipH="1">
+            <a:off x="7155180" y="5422392"/>
+            <a:ext cx="640080" cy="566928"/>
+          </a:xfrm>
+          <a:prstGeom prst="line">
+            <a:avLst/>
+          </a:prstGeom>
+          <a:ln w="17780">
+            <a:solidFill>
+              <a:srgbClr val="222222"/>
+            </a:solidFill>
+            <a:tailEnd type="triangle" w="med" len="med"/>
+          </a:ln>
+        </p:spPr>
+        <p:style>
+          <a:lnRef idx="2">
+            <a:schemeClr val="accent1"/>
+          </a:lnRef>
+          <a:fillRef idx="0">
+            <a:schemeClr val="accent1"/>
+          </a:fillRef>
+          <a:effectRef idx="1">
+            <a:schemeClr val="accent1"/>
+          </a:effectRef>
+          <a:fontRef idx="minor">
+            <a:schemeClr val="tx1"/>
+          </a:fontRef>
+        </p:style>
+      </p:cxnSp>
+      <p:cxnSp>
+        <p:nvCxnSpPr>
+          <p:cNvPr id="65" name="Connector 64"/>
+          <p:cNvCxnSpPr/>
+          <p:nvPr/>
+        </p:nvCxnSpPr>
+        <p:spPr>
+          <a:xfrm>
+            <a:off x="5212079" y="3630168"/>
+            <a:ext cx="1691641" cy="0"/>
+          </a:xfrm>
+          <a:prstGeom prst="line">
+            <a:avLst/>
+          </a:prstGeom>
+          <a:ln w="17780">
+            <a:solidFill>
+              <a:srgbClr val="222222"/>
+            </a:solidFill>
+            <a:tailEnd type="triangle" w="med" len="med"/>
+          </a:ln>
+        </p:spPr>
+        <p:style>
+          <a:lnRef idx="2">
+            <a:schemeClr val="accent1"/>
+          </a:lnRef>
+          <a:fillRef idx="0">
+            <a:schemeClr val="accent1"/>
+          </a:fillRef>
+          <a:effectRef idx="1">
+            <a:schemeClr val="accent1"/>
+          </a:effectRef>
+          <a:fontRef idx="minor">
+            <a:schemeClr val="tx1"/>
+          </a:fontRef>
+        </p:style>
+      </p:cxnSp>
+      <p:sp>
+        <p:nvSpPr>
+          <p:cNvPr id="66" name="TextBox 65"/>
+          <p:cNvSpPr txBox="1"/>
+          <p:nvPr/>
+        </p:nvSpPr>
+        <p:spPr>
+          <a:xfrm>
+            <a:off x="5257799" y="3145536"/>
+            <a:ext cx="1234440" cy="237744"/>
+          </a:xfrm>
+          <a:prstGeom prst="rect">
+            <a:avLst/>
+          </a:prstGeom>
+          <a:noFill/>
+        </p:spPr>
+        <p:txBody>
+          <a:bodyPr wrap="square" anchor="ctr"/>
+          <a:lstStyle/>
+          <a:p>
+            <a:pPr algn="l"/>
+            <a:r>
+              <a:rPr sz="900" b="0">
+                <a:solidFill>
+                  <a:srgbClr val="C96C16"/>
+                </a:solidFill>
+                <a:latin typeface="微软雅黑"/>
+                <a:ea typeface="微软雅黑"/>
+              </a:rPr>
+              <a:t>GLES叠加</a:t>
+            </a:r>
+          </a:p>
+        </p:txBody>
+      </p:sp>
+      <p:cxnSp>
+        <p:nvCxnSpPr>
+          <p:cNvPr id="67" name="Connector 66"/>
+          <p:cNvCxnSpPr/>
+          <p:nvPr/>
+        </p:nvCxnSpPr>
+        <p:spPr>
+          <a:xfrm>
+            <a:off x="9601200" y="3145536"/>
+            <a:ext cx="388619" cy="0"/>
+          </a:xfrm>
+          <a:prstGeom prst="line">
+            <a:avLst/>
+          </a:prstGeom>
+          <a:ln w="22225">
+            <a:solidFill>
+              <a:srgbClr val="2F6FD4"/>
+            </a:solidFill>
+            <a:tailEnd type="triangle" w="med" len="med"/>
+          </a:ln>
+        </p:spPr>
+        <p:style>
+          <a:lnRef idx="2">
+            <a:schemeClr val="accent1"/>
+          </a:lnRef>
+          <a:fillRef idx="0">
+            <a:schemeClr val="accent1"/>
+          </a:fillRef>
+          <a:effectRef idx="1">
+            <a:schemeClr val="accent1"/>
+          </a:effectRef>
+          <a:fontRef idx="minor">
+            <a:schemeClr val="tx1"/>
+          </a:fontRef>
+        </p:style>
+      </p:cxnSp>
+      <p:cxnSp>
+        <p:nvCxnSpPr>
+          <p:cNvPr id="68" name="Connector 67"/>
+          <p:cNvCxnSpPr/>
+          <p:nvPr/>
+        </p:nvCxnSpPr>
+        <p:spPr>
+          <a:xfrm flipH="1">
+            <a:off x="9852660" y="4206240"/>
+            <a:ext cx="137159" cy="713232"/>
+          </a:xfrm>
+          <a:prstGeom prst="line">
+            <a:avLst/>
+          </a:prstGeom>
+          <a:ln w="22225">
+            <a:solidFill>
+              <a:srgbClr val="2F6FD4"/>
+            </a:solidFill>
+            <a:tailEnd type="triangle" w="med" len="med"/>
+          </a:ln>
+        </p:spPr>
+        <p:style>
+          <a:lnRef idx="2">
+            <a:schemeClr val="accent1"/>
+          </a:lnRef>
+          <a:fillRef idx="0">
+            <a:schemeClr val="accent1"/>
+          </a:fillRef>
+          <a:effectRef idx="1">
+            <a:schemeClr val="accent1"/>
+          </a:effectRef>
+          <a:fontRef idx="minor">
+            <a:schemeClr val="tx1"/>
+          </a:fontRef>
+        </p:style>
+      </p:cxnSp>
+      <p:cxnSp>
+        <p:nvCxnSpPr>
+          <p:cNvPr id="69" name="Connector 68"/>
+          <p:cNvCxnSpPr/>
+          <p:nvPr/>
+        </p:nvCxnSpPr>
+        <p:spPr>
+          <a:xfrm flipH="1">
+            <a:off x="8709660" y="5170932"/>
+            <a:ext cx="480060" cy="0"/>
+          </a:xfrm>
+          <a:prstGeom prst="line">
+            <a:avLst/>
+          </a:prstGeom>
+          <a:ln w="22225">
+            <a:solidFill>
+              <a:srgbClr val="2F6FD4"/>
+            </a:solidFill>
+            <a:tailEnd type="triangle" w="med" len="med"/>
+          </a:ln>
+        </p:spPr>
+        <p:style>
+          <a:lnRef idx="2">
+            <a:schemeClr val="accent1"/>
+          </a:lnRef>
+          <a:fillRef idx="0">
+            <a:schemeClr val="accent1"/>
+          </a:fillRef>
+          <a:effectRef idx="1">
+            <a:schemeClr val="accent1"/>
+          </a:effectRef>
+          <a:fontRef idx="minor">
+            <a:schemeClr val="tx1"/>
+          </a:fontRef>
+        </p:style>
+      </p:cxnSp>
+      <p:sp>
+        <p:nvSpPr>
+          <p:cNvPr id="70" name="TextBox 69"/>
+          <p:cNvSpPr txBox="1"/>
+          <p:nvPr/>
+        </p:nvSpPr>
+        <p:spPr>
+          <a:xfrm>
+            <a:off x="7955280" y="4663440"/>
+            <a:ext cx="1280160" cy="237744"/>
+          </a:xfrm>
+          <a:prstGeom prst="rect">
+            <a:avLst/>
+          </a:prstGeom>
+          <a:noFill/>
+        </p:spPr>
+        <p:txBody>
+          <a:bodyPr wrap="square" anchor="ctr"/>
+          <a:lstStyle/>
+          <a:p>
+            <a:pPr algn="l"/>
+            <a:r>
+              <a:rPr sz="900" b="0">
+                <a:solidFill>
+                  <a:srgbClr val="2F6FD4"/>
+                </a:solidFill>
+                <a:latin typeface="微软雅黑"/>
+                <a:ea typeface="微软雅黑"/>
+              </a:rPr>
+              <a:t>叠加 Compose</a:t>
+            </a:r>
+          </a:p>
+        </p:txBody>
+      </p:sp>
+      <p:cxnSp>
+        <p:nvCxnSpPr>
+          <p:cNvPr id="71" name="Connector 70"/>
+          <p:cNvCxnSpPr/>
+          <p:nvPr/>
+        </p:nvCxnSpPr>
+        <p:spPr>
+          <a:xfrm>
+            <a:off x="9852660" y="5422392"/>
+            <a:ext cx="411480" cy="566928"/>
+          </a:xfrm>
+          <a:prstGeom prst="line">
+            <a:avLst/>
+          </a:prstGeom>
+          <a:ln w="22225">
+            <a:solidFill>
+              <a:srgbClr val="2F6FD4"/>
+            </a:solidFill>
+            <a:tailEnd type="triangle" w="med" len="med"/>
+          </a:ln>
+        </p:spPr>
+        <p:style>
+          <a:lnRef idx="2">
+            <a:schemeClr val="accent1"/>
+          </a:lnRef>
+          <a:fillRef idx="0">
+            <a:schemeClr val="accent1"/>
+          </a:fillRef>
+          <a:effectRef idx="1">
+            <a:schemeClr val="accent1"/>
+          </a:effectRef>
+          <a:fontRef idx="minor">
+            <a:schemeClr val="tx1"/>
+          </a:fontRef>
+        </p:style>
+      </p:cxnSp>
+      <p:sp>
+        <p:nvSpPr>
+          <p:cNvPr id="72" name="TextBox 71"/>
+          <p:cNvSpPr txBox="1"/>
+          <p:nvPr/>
+        </p:nvSpPr>
+        <p:spPr>
+          <a:xfrm>
+            <a:off x="10332720" y="5422392"/>
+            <a:ext cx="822960" cy="219456"/>
+          </a:xfrm>
+          <a:prstGeom prst="rect">
+            <a:avLst/>
+          </a:prstGeom>
+          <a:noFill/>
+        </p:spPr>
+        <p:txBody>
+          <a:bodyPr wrap="square" anchor="ctr"/>
+          <a:lstStyle/>
+          <a:p>
+            <a:pPr algn="l"/>
+            <a:r>
+              <a:rPr sz="900" b="0">
+                <a:solidFill>
+                  <a:srgbClr val="2F6FD4"/>
+                </a:solidFill>
+                <a:latin typeface="微软雅黑"/>
+                <a:ea typeface="微软雅黑"/>
+              </a:rPr>
+              <a:t>刷新</a:t>
+            </a:r>
+          </a:p>
+        </p:txBody>
+      </p:sp>
+      <p:cxnSp>
+        <p:nvCxnSpPr>
+          <p:cNvPr id="73" name="Connector 72"/>
+          <p:cNvCxnSpPr/>
+          <p:nvPr/>
+        </p:nvCxnSpPr>
+        <p:spPr>
+          <a:xfrm>
+            <a:off x="10515600" y="5170932"/>
+            <a:ext cx="502920" cy="0"/>
+          </a:xfrm>
+          <a:prstGeom prst="line">
+            <a:avLst/>
+          </a:prstGeom>
+          <a:ln w="22225">
+            <a:solidFill>
+              <a:srgbClr val="D4A012"/>
+            </a:solidFill>
+            <a:tailEnd type="triangle" w="med" len="med"/>
+          </a:ln>
+        </p:spPr>
+        <p:style>
+          <a:lnRef idx="2">
+            <a:schemeClr val="accent1"/>
+          </a:lnRef>
+          <a:fillRef idx="0">
+            <a:schemeClr val="accent1"/>
+          </a:fillRef>
+          <a:effectRef idx="1">
+            <a:schemeClr val="accent1"/>
+          </a:effectRef>
+          <a:fontRef idx="minor">
+            <a:schemeClr val="tx1"/>
+          </a:fontRef>
+        </p:style>
+      </p:cxnSp>
+      <p:cxnSp>
+        <p:nvCxnSpPr>
+          <p:cNvPr id="74" name="Connector 73"/>
+          <p:cNvCxnSpPr/>
+          <p:nvPr/>
+        </p:nvCxnSpPr>
+        <p:spPr>
+          <a:xfrm>
+            <a:off x="11681460" y="5422392"/>
+            <a:ext cx="137160" cy="566928"/>
+          </a:xfrm>
+          <a:prstGeom prst="line">
+            <a:avLst/>
+          </a:prstGeom>
+          <a:ln w="22225">
+            <a:solidFill>
+              <a:srgbClr val="D4A012"/>
+            </a:solidFill>
+            <a:tailEnd type="triangle" w="med" len="med"/>
+          </a:ln>
+        </p:spPr>
+        <p:style>
+          <a:lnRef idx="2">
+            <a:schemeClr val="accent1"/>
+          </a:lnRef>
+          <a:fillRef idx="0">
+            <a:schemeClr val="accent1"/>
+          </a:fillRef>
+          <a:effectRef idx="1">
+            <a:schemeClr val="accent1"/>
+          </a:effectRef>
+          <a:fontRef idx="minor">
+            <a:schemeClr val="tx1"/>
+          </a:fontRef>
+        </p:style>
+      </p:cxnSp>
+      <p:sp>
+        <p:nvSpPr>
+          <p:cNvPr id="75" name="TextBox 74"/>
+          <p:cNvSpPr txBox="1"/>
+          <p:nvPr/>
+        </p:nvSpPr>
+        <p:spPr>
+          <a:xfrm>
+            <a:off x="12207240" y="5422392"/>
+            <a:ext cx="1005840" cy="219456"/>
+          </a:xfrm>
+          <a:prstGeom prst="rect">
+            <a:avLst/>
+          </a:prstGeom>
+          <a:noFill/>
+        </p:spPr>
+        <p:txBody>
+          <a:bodyPr wrap="square" anchor="ctr"/>
+          <a:lstStyle/>
+          <a:p>
+            <a:pPr algn="l"/>
+            <a:r>
+              <a:rPr sz="900" b="0">
+                <a:solidFill>
+                  <a:srgbClr val="D4A012"/>
+                </a:solidFill>
+                <a:latin typeface="微软雅黑"/>
+                <a:ea typeface="微软雅黑"/>
+              </a:rPr>
+              <a:t>独立送显</a:t>
+            </a:r>
+          </a:p>
+        </p:txBody>
+      </p:sp>
+      <p:sp>
+        <p:nvSpPr>
+          <p:cNvPr id="76" name="TextBox 75"/>
+          <p:cNvSpPr txBox="1"/>
+          <p:nvPr/>
+        </p:nvSpPr>
+        <p:spPr>
+          <a:xfrm>
+            <a:off x="109728" y="164592"/>
+            <a:ext cx="1234440" cy="256032"/>
+          </a:xfrm>
+          <a:prstGeom prst="rect">
+            <a:avLst/>
+          </a:prstGeom>
+          <a:noFill/>
+        </p:spPr>
+        <p:txBody>
+          <a:bodyPr wrap="square" anchor="ctr"/>
+          <a:lstStyle/>
+          <a:p>
+            <a:pPr algn="l"/>
+            <a:r>
+              <a:rPr sz="1100" b="1">
+                <a:solidFill>
+                  <a:srgbClr val="162A5A"/>
+                </a:solidFill>
+                <a:latin typeface="微软雅黑"/>
+                <a:ea typeface="微软雅黑"/>
+              </a:rPr>
+              <a:t>图例</a:t>
+            </a:r>
+          </a:p>
+        </p:txBody>
+      </p:sp>
+      <p:cxnSp>
+        <p:nvCxnSpPr>
+          <p:cNvPr id="77" name="Connector 76"/>
+          <p:cNvCxnSpPr/>
+          <p:nvPr/>
+        </p:nvCxnSpPr>
+        <p:spPr>
+          <a:xfrm>
+            <a:off x="164592" y="530352"/>
+            <a:ext cx="704088" cy="0"/>
+          </a:xfrm>
+          <a:prstGeom prst="line">
+            <a:avLst/>
+          </a:prstGeom>
+          <a:ln w="22225">
+            <a:solidFill>
+              <a:srgbClr val="D03232"/>
+            </a:solidFill>
+            <a:tailEnd type="triangle" w="med" len="med"/>
+          </a:ln>
+        </p:spPr>
+        <p:style>
+          <a:lnRef idx="2">
+            <a:schemeClr val="accent1"/>
+          </a:lnRef>
+          <a:fillRef idx="0">
+            <a:schemeClr val="accent1"/>
+          </a:fillRef>
+          <a:effectRef idx="1">
+            <a:schemeClr val="accent1"/>
+          </a:effectRef>
+          <a:fontRef idx="minor">
+            <a:schemeClr val="tx1"/>
+          </a:fontRef>
+        </p:style>
+      </p:cxnSp>
+      <p:sp>
+        <p:nvSpPr>
+          <p:cNvPr id="78" name="TextBox 77"/>
+          <p:cNvSpPr txBox="1"/>
+          <p:nvPr/>
+        </p:nvSpPr>
+        <p:spPr>
+          <a:xfrm>
+            <a:off x="109728" y="566928"/>
+            <a:ext cx="1234440" cy="256032"/>
+          </a:xfrm>
+          <a:prstGeom prst="rect">
+            <a:avLst/>
+          </a:prstGeom>
+          <a:noFill/>
+        </p:spPr>
+        <p:txBody>
+          <a:bodyPr wrap="square" anchor="ctr"/>
+          <a:lstStyle/>
+          <a:p>
+            <a:pPr algn="l"/>
+            <a:r>
+              <a:rPr sz="1000" b="0">
+                <a:solidFill>
+                  <a:srgbClr val="D03232"/>
+                </a:solidFill>
+                <a:latin typeface="微软雅黑"/>
+                <a:ea typeface="微软雅黑"/>
+              </a:rPr>
+              <a:t>绘制通路</a:t>
+            </a:r>
+          </a:p>
+        </p:txBody>
+      </p:sp>
+      <p:cxnSp>
+        <p:nvCxnSpPr>
+          <p:cNvPr id="79" name="Connector 78"/>
+          <p:cNvCxnSpPr/>
+          <p:nvPr/>
+        </p:nvCxnSpPr>
+        <p:spPr>
+          <a:xfrm>
+            <a:off x="164592" y="932688"/>
+            <a:ext cx="704088" cy="0"/>
+          </a:xfrm>
+          <a:prstGeom prst="line">
+            <a:avLst/>
+          </a:prstGeom>
+          <a:ln w="22225">
+            <a:solidFill>
+              <a:srgbClr val="2F6FD4"/>
+            </a:solidFill>
+            <a:tailEnd type="triangle" w="med" len="med"/>
+          </a:ln>
+        </p:spPr>
+        <p:style>
+          <a:lnRef idx="2">
+            <a:schemeClr val="accent1"/>
+          </a:lnRef>
+          <a:fillRef idx="0">
+            <a:schemeClr val="accent1"/>
+          </a:fillRef>
+          <a:effectRef idx="1">
+            <a:schemeClr val="accent1"/>
+          </a:effectRef>
+          <a:fontRef idx="minor">
+            <a:schemeClr val="tx1"/>
+          </a:fontRef>
+        </p:style>
+      </p:cxnSp>
+      <p:sp>
+        <p:nvSpPr>
+          <p:cNvPr id="80" name="TextBox 79"/>
+          <p:cNvSpPr txBox="1"/>
+          <p:nvPr/>
+        </p:nvSpPr>
+        <p:spPr>
+          <a:xfrm>
+            <a:off x="109728" y="969264"/>
+            <a:ext cx="1234440" cy="256032"/>
+          </a:xfrm>
+          <a:prstGeom prst="rect">
+            <a:avLst/>
+          </a:prstGeom>
+          <a:noFill/>
+        </p:spPr>
+        <p:txBody>
+          <a:bodyPr wrap="square" anchor="ctr"/>
+          <a:lstStyle/>
+          <a:p>
+            <a:pPr algn="l"/>
+            <a:r>
+              <a:rPr sz="1000" b="0">
+                <a:solidFill>
+                  <a:srgbClr val="2F6FD4"/>
+                </a:solidFill>
+                <a:latin typeface="微软雅黑"/>
+                <a:ea typeface="微软雅黑"/>
+              </a:rPr>
+              <a:t>叠加通路</a:t>
+            </a:r>
+          </a:p>
+        </p:txBody>
+      </p:sp>
+      <p:cxnSp>
+        <p:nvCxnSpPr>
+          <p:cNvPr id="81" name="Connector 80"/>
+          <p:cNvCxnSpPr/>
+          <p:nvPr/>
+        </p:nvCxnSpPr>
+        <p:spPr>
+          <a:xfrm>
+            <a:off x="164592" y="1335024"/>
+            <a:ext cx="704088" cy="0"/>
+          </a:xfrm>
+          <a:prstGeom prst="line">
+            <a:avLst/>
+          </a:prstGeom>
+          <a:ln w="22225">
+            <a:solidFill>
+              <a:srgbClr val="D4A012"/>
+            </a:solidFill>
+            <a:tailEnd type="triangle" w="med" len="med"/>
+          </a:ln>
+        </p:spPr>
+        <p:style>
+          <a:lnRef idx="2">
+            <a:schemeClr val="accent1"/>
+          </a:lnRef>
+          <a:fillRef idx="0">
+            <a:schemeClr val="accent1"/>
+          </a:fillRef>
+          <a:effectRef idx="1">
+            <a:schemeClr val="accent1"/>
+          </a:effectRef>
+          <a:fontRef idx="minor">
+            <a:schemeClr val="tx1"/>
+          </a:fontRef>
+        </p:style>
+      </p:cxnSp>
+      <p:sp>
+        <p:nvSpPr>
+          <p:cNvPr id="82" name="TextBox 81"/>
+          <p:cNvSpPr txBox="1"/>
+          <p:nvPr/>
+        </p:nvSpPr>
+        <p:spPr>
+          <a:xfrm>
+            <a:off x="109728" y="1371600"/>
+            <a:ext cx="1234440" cy="256032"/>
+          </a:xfrm>
+          <a:prstGeom prst="rect">
+            <a:avLst/>
+          </a:prstGeom>
+          <a:noFill/>
+        </p:spPr>
+        <p:txBody>
+          <a:bodyPr wrap="square" anchor="ctr"/>
+          <a:lstStyle/>
+          <a:p>
+            <a:pPr algn="l"/>
+            <a:r>
+              <a:rPr sz="1000" b="0">
+                <a:solidFill>
+                  <a:srgbClr val="D4A012"/>
+                </a:solidFill>
+                <a:latin typeface="微软雅黑"/>
+                <a:ea typeface="微软雅黑"/>
+              </a:rPr>
+              <a:t>送显通路</a:t>
+            </a:r>
+          </a:p>
+        </p:txBody>
+      </p:sp>
+      <p:cxnSp>
+        <p:nvCxnSpPr>
+          <p:cNvPr id="83" name="Connector 82"/>
+          <p:cNvCxnSpPr/>
+          <p:nvPr/>
+        </p:nvCxnSpPr>
+        <p:spPr>
+          <a:xfrm>
+            <a:off x="164592" y="1737360"/>
+            <a:ext cx="704088" cy="0"/>
+          </a:xfrm>
+          <a:prstGeom prst="line">
+            <a:avLst/>
+          </a:prstGeom>
+          <a:ln w="22225">
+            <a:solidFill>
+              <a:srgbClr val="C96C16"/>
+            </a:solidFill>
+            <a:tailEnd type="triangle" w="med" len="med"/>
+          </a:ln>
+        </p:spPr>
+        <p:style>
+          <a:lnRef idx="2">
+            <a:schemeClr val="accent1"/>
+          </a:lnRef>
+          <a:fillRef idx="0">
+            <a:schemeClr val="accent1"/>
+          </a:fillRef>
+          <a:effectRef idx="1">
+            <a:schemeClr val="accent1"/>
+          </a:effectRef>
+          <a:fontRef idx="minor">
+            <a:schemeClr val="tx1"/>
+          </a:fontRef>
+        </p:style>
+      </p:cxnSp>
+      <p:sp>
+        <p:nvSpPr>
+          <p:cNvPr id="84" name="TextBox 83"/>
+          <p:cNvSpPr txBox="1"/>
+          <p:nvPr/>
+        </p:nvSpPr>
+        <p:spPr>
+          <a:xfrm>
+            <a:off x="109728" y="1773936"/>
+            <a:ext cx="1234440" cy="365760"/>
+          </a:xfrm>
+          <a:prstGeom prst="rect">
+            <a:avLst/>
+          </a:prstGeom>
+          <a:noFill/>
+        </p:spPr>
+        <p:txBody>
+          <a:bodyPr wrap="square" anchor="ctr"/>
+          <a:lstStyle/>
+          <a:p>
+            <a:pPr algn="l"/>
+            <a:r>
+              <a:rPr sz="1000" b="1">
+                <a:solidFill>
+                  <a:srgbClr val="C96C16"/>
+                </a:solidFill>
+                <a:latin typeface="微软雅黑"/>
+                <a:ea typeface="微软雅黑"/>
+              </a:rPr>
+              <a:t>软渲染
+SwiftShader</a:t>
+            </a:r>
+          </a:p>
+        </p:txBody>
+      </p:sp>
+      <p:sp>
+        <p:nvSpPr>
+          <p:cNvPr id="85" name="TextBox 84"/>
+          <p:cNvSpPr txBox="1"/>
+          <p:nvPr/>
+        </p:nvSpPr>
+        <p:spPr>
+          <a:xfrm>
+            <a:off x="91440" y="4800600"/>
+            <a:ext cx="1280160" cy="777240"/>
+          </a:xfrm>
+          <a:prstGeom prst="rect">
+            <a:avLst/>
+          </a:prstGeom>
+          <a:noFill/>
+        </p:spPr>
+        <p:txBody>
+          <a:bodyPr wrap="square" anchor="ctr"/>
+          <a:lstStyle/>
+          <a:p>
+            <a:pPr algn="l"/>
+            <a:r>
+              <a:rPr sz="900" b="0">
+                <a:solidFill>
+                  <a:srgbClr val="666666"/>
+                </a:solidFill>
+                <a:latin typeface="微软雅黑"/>
+                <a:ea typeface="微软雅黑"/>
+              </a:rPr>
+              <a:t>HAL：guest 下 HWC 弱，合成常退回 GLES。</a:t>
+            </a:r>
+          </a:p>
+        </p:txBody>
+      </p:sp>
+      <p:sp>
+        <p:nvSpPr>
+          <p:cNvPr id="86" name="TextBox 85"/>
+          <p:cNvSpPr txBox="1"/>
+          <p:nvPr/>
+        </p:nvSpPr>
+        <p:spPr>
+          <a:xfrm>
+            <a:off x="91440" y="5806440"/>
+            <a:ext cx="1280160" cy="1463040"/>
+          </a:xfrm>
+          <a:prstGeom prst="rect">
+            <a:avLst/>
+          </a:prstGeom>
+          <a:noFill/>
+        </p:spPr>
+        <p:txBody>
+          <a:bodyPr wrap="square" anchor="ctr"/>
+          <a:lstStyle/>
+          <a:p>
+            <a:pPr algn="l"/>
+            <a:r>
+              <a:rPr sz="900" b="0">
+                <a:solidFill>
+                  <a:srgbClr val="C96C16"/>
+                </a:solidFill>
+                <a:latin typeface="微软雅黑"/>
+                <a:ea typeface="微软雅黑"/>
+              </a:rPr>
+              <a:t>Kernel GPU / 硬解 / 叠加加速器：本沙箱旁路。像素由 CPU 上的 SwiftShader 填。</a:t>
+            </a:r>
+          </a:p>
+        </p:txBody>
+      </p:sp>
+      <p:sp>
+        <p:nvSpPr>
+          <p:cNvPr id="87" name="TextBox 86"/>
+          <p:cNvSpPr txBox="1"/>
+          <p:nvPr/>
+        </p:nvSpPr>
+        <p:spPr>
+          <a:xfrm>
+            <a:off x="1417320" y="7882127"/>
+            <a:ext cx="12938760" cy="292608"/>
+          </a:xfrm>
+          <a:prstGeom prst="rect">
+            <a:avLst/>
+          </a:prstGeom>
+          <a:noFill/>
+        </p:spPr>
+        <p:txBody>
+          <a:bodyPr wrap="square" anchor="ctr"/>
+          <a:lstStyle/>
+          <a:p>
+            <a:pPr algn="l"/>
+            <a:r>
+              <a:rPr sz="1100" b="0">
+                <a:solidFill>
+                  <a:srgbClr val="162A5A"/>
+                </a:solidFill>
+                <a:latin typeface="微软雅黑"/>
+                <a:ea typeface="微软雅黑"/>
+              </a:rPr>
+              <a:t>本沙箱：MicroVM + ReDroid，androidboot.redroid_gpu_mode=guest。HWUI / SF 仍下单；SwiftShader 用 CPU 填像素；GPU 虚线为真机原路，本沙箱不走。</a:t>
+            </a:r>
+          </a:p>
+        </p:txBody>
+      </p:sp>
+    </p:spTree>
+  </p:cSld>
+  <p:clrMapOvr>
+    <a:masterClrMapping/>
+  </p:clrMapOvr>
+</p:sld>
+</file>
+
+<file path=ppt/slides/slide5.xml><?xml version="1.0" encoding="utf-8"?>
 <p:sld xmlns:a="http://schemas.openxmlformats.org/drawingml/2006/main" xmlns:p="http://schemas.openxmlformats.org/presentationml/2006/main" xmlns:r="http://schemas.openxmlformats.org/officeDocument/2006/relationships">
   <p:cSld>
     <p:spTree>

</xml_diff>

<commit_message>
docs: rename Android Native layer to 系统库 for leadership slides
Autonomously-by: Cursor-Grok:4.6

Co-authored-by: fangyushanghai <fangyushanghai@gmail.com>
</commit_message>
<xml_diff>
--- a/docs/assets/android-graphics-stack-wireframe.pptx
+++ b/docs/assets/android-graphics-stack-wireframe.pptx
@@ -3400,7 +3400,7 @@
                 <a:latin typeface="微软雅黑"/>
                 <a:ea typeface="微软雅黑"/>
               </a:rPr>
-              <a:t>Native</a:t>
+              <a:t>系统库</a:t>
             </a:r>
           </a:p>
         </p:txBody>
@@ -6887,7 +6887,7 @@
                 <a:latin typeface="微软雅黑"/>
                 <a:ea typeface="微软雅黑"/>
               </a:rPr>
-              <a:t>Native</a:t>
+              <a:t>系统库</a:t>
             </a:r>
           </a:p>
         </p:txBody>
@@ -10119,7 +10119,7 @@
                 <a:latin typeface="微软雅黑"/>
                 <a:ea typeface="微软雅黑"/>
               </a:rPr>
-              <a:t>落点：Native 层 OpenGL ES 的实现。不是 Kernel GPU，也不是 SurfaceFlinger / HWC。</a:t>
+              <a:t>落点：系统库这一层的 OpenGL ES 实现。不是内核 GPU，也不是 SurfaceFlinger / HWC。</a:t>
             </a:r>
           </a:p>
         </p:txBody>
@@ -10374,7 +10374,7 @@
                 <a:latin typeface="微软雅黑"/>
                 <a:ea typeface="微软雅黑"/>
               </a:rPr>
-              <a:t>Native</a:t>
+              <a:t>系统库</a:t>
             </a:r>
           </a:p>
         </p:txBody>
@@ -13939,7 +13939,7 @@
                 <a:latin typeface="微软雅黑"/>
                 <a:ea typeface="微软雅黑"/>
               </a:rPr>
-              <a:t>Native 层，Open GL ES 这一格的实现。对应原图红线：HWUI / Skia / libRS → Open GL ES → GPU。本沙箱在 Open GL ES 处截住，不再进 Kernel 的 GPU。</a:t>
+              <a:t>系统库这一层，Open GL ES 这一格的实现。对应原图红线：HWUI / Skia / libRS → Open GL ES → GPU。本沙箱在 Open GL ES 处截住，不再进内核 GPU。</a:t>
             </a:r>
           </a:p>
         </p:txBody>
@@ -14657,7 +14657,7 @@
                 <a:latin typeface="微软雅黑"/>
                 <a:ea typeface="微软雅黑"/>
               </a:rPr>
-              <a:t>一句话：画在 Native 的 Open GL ES 上，替掉到 GPU 的绘制红线；不要画成一层新 HAL，也不要画进 Kernel。</a:t>
+              <a:t>一句话：画在系统库的 Open GL ES 上，替掉到 GPU 的绘制红线；不要画成一层新硬件接口，也不要画进内核。</a:t>
             </a:r>
           </a:p>
         </p:txBody>

</xml_diff>